<commit_message>
Add GitHub repository URL to final deliverables
</commit_message>
<xml_diff>
--- a/final-deliverables/SpaceX_Falcon9_Final_Presentation.pptx
+++ b/final-deliverables/SpaceX_Falcon9_Final_Presentation.pptx
@@ -2,25 +2,25 @@
 <file path=ppt/presentation.xml><?xml version="1.0" encoding="utf-8"?>
 <p:presentation xmlns:p="http://schemas.openxmlformats.org/presentationml/2006/main">
   <p:sldMasterIdLst>
-    <p:sldMasterId xmlns:r="http://schemas.openxmlformats.org/officeDocument/2006/relationships" id="2147483648" r:id="R134123bd47424af9"/>
+    <p:sldMasterId xmlns:r="http://schemas.openxmlformats.org/officeDocument/2006/relationships" id="2147483648" r:id="R5081a0a728fc4408"/>
   </p:sldMasterIdLst>
   <p:notesMasterIdLst>
-    <p:notesMasterId xmlns:r="http://schemas.openxmlformats.org/officeDocument/2006/relationships" r:id="Rb323ee6c4e7a41e3"/>
+    <p:notesMasterId xmlns:r="http://schemas.openxmlformats.org/officeDocument/2006/relationships" r:id="R3035b4e9eb2a4a82"/>
   </p:notesMasterIdLst>
   <p:sldIdLst>
-    <p:sldId xmlns:r="http://schemas.openxmlformats.org/officeDocument/2006/relationships" id="256" r:id="R3534c1ba57ca4e7a"/>
-    <p:sldId xmlns:r="http://schemas.openxmlformats.org/officeDocument/2006/relationships" id="257" r:id="Rf05bd059c55d45b5"/>
-    <p:sldId xmlns:r="http://schemas.openxmlformats.org/officeDocument/2006/relationships" id="258" r:id="R6f5604421899461b"/>
-    <p:sldId xmlns:r="http://schemas.openxmlformats.org/officeDocument/2006/relationships" id="259" r:id="R1249f21c0d2842b3"/>
-    <p:sldId xmlns:r="http://schemas.openxmlformats.org/officeDocument/2006/relationships" id="260" r:id="Rd0221bfcf90a44d7"/>
-    <p:sldId xmlns:r="http://schemas.openxmlformats.org/officeDocument/2006/relationships" id="261" r:id="R62b8ac79bff54e9e"/>
-    <p:sldId xmlns:r="http://schemas.openxmlformats.org/officeDocument/2006/relationships" id="262" r:id="R74a44b1af7224d10"/>
-    <p:sldId xmlns:r="http://schemas.openxmlformats.org/officeDocument/2006/relationships" id="263" r:id="R31ba9a4ffae54a33"/>
-    <p:sldId xmlns:r="http://schemas.openxmlformats.org/officeDocument/2006/relationships" id="264" r:id="R0f272e56091748ee"/>
-    <p:sldId xmlns:r="http://schemas.openxmlformats.org/officeDocument/2006/relationships" id="265" r:id="Rd87e995c396f43c9"/>
-    <p:sldId xmlns:r="http://schemas.openxmlformats.org/officeDocument/2006/relationships" id="266" r:id="R8fcef267a00f439a"/>
-    <p:sldId xmlns:r="http://schemas.openxmlformats.org/officeDocument/2006/relationships" id="267" r:id="Rde8d1b4c09184174"/>
-    <p:sldId xmlns:r="http://schemas.openxmlformats.org/officeDocument/2006/relationships" id="268" r:id="R57259662e5c94026"/>
+    <p:sldId xmlns:r="http://schemas.openxmlformats.org/officeDocument/2006/relationships" id="256" r:id="Re80bbf865b9f4274"/>
+    <p:sldId xmlns:r="http://schemas.openxmlformats.org/officeDocument/2006/relationships" id="257" r:id="Rf5ffe3c42d594259"/>
+    <p:sldId xmlns:r="http://schemas.openxmlformats.org/officeDocument/2006/relationships" id="258" r:id="R8024f5c05ab34f44"/>
+    <p:sldId xmlns:r="http://schemas.openxmlformats.org/officeDocument/2006/relationships" id="259" r:id="R5a26d2c55592435d"/>
+    <p:sldId xmlns:r="http://schemas.openxmlformats.org/officeDocument/2006/relationships" id="260" r:id="Rf7fe5876a2394b11"/>
+    <p:sldId xmlns:r="http://schemas.openxmlformats.org/officeDocument/2006/relationships" id="261" r:id="Rd4bb823205344e8e"/>
+    <p:sldId xmlns:r="http://schemas.openxmlformats.org/officeDocument/2006/relationships" id="262" r:id="R1e2ea19e9d5345c2"/>
+    <p:sldId xmlns:r="http://schemas.openxmlformats.org/officeDocument/2006/relationships" id="263" r:id="R3ae195433cf747eb"/>
+    <p:sldId xmlns:r="http://schemas.openxmlformats.org/officeDocument/2006/relationships" id="264" r:id="R0c0b6ab1fd194dd2"/>
+    <p:sldId xmlns:r="http://schemas.openxmlformats.org/officeDocument/2006/relationships" id="265" r:id="R4076e71b3855437a"/>
+    <p:sldId xmlns:r="http://schemas.openxmlformats.org/officeDocument/2006/relationships" id="266" r:id="Re174a87ef3b946eb"/>
+    <p:sldId xmlns:r="http://schemas.openxmlformats.org/officeDocument/2006/relationships" id="267" r:id="R0810f202c7614972"/>
+    <p:sldId xmlns:r="http://schemas.openxmlformats.org/officeDocument/2006/relationships" id="268" r:id="R8b9d3c7df1f34948"/>
   </p:sldIdLst>
   <p:sldSz cx="12192000" cy="6858000"/>
   <p:notesSz cx="6858000" cy="9144000"/>
@@ -762,6 +762,11 @@
               <a:t>- Local project assets supplied by the user.</a:t>
             </a:r>
           </a:p>
+          <a:p xmlns:a="http://schemas.openxmlformats.org/drawingml/2006/main">
+            <a:r>
+              <a:t>- https://github.com/TristinWen/spacex-falcon9-landing-prediction</a:t>
+            </a:r>
+          </a:p>
         </p:txBody>
       </p:sp>
       <p:sp>
@@ -1447,7 +1452,7 @@
   </p:cSld>
   <p:clrMap bg1="lt1" tx1="dk1" bg2="lt2" tx2="dk2" accent1="accent1" accent2="accent2" accent3="accent3" accent4="accent4" accent5="accent5" accent6="accent6" hlink="hlink" folHlink="folHlink"/>
   <p:sldLayoutIdLst>
-    <p:sldLayoutId xmlns:r="http://schemas.openxmlformats.org/officeDocument/2006/relationships" id="2147483649" r:id="R4d5ccff9adad4bc8"/>
+    <p:sldLayoutId xmlns:r="http://schemas.openxmlformats.org/officeDocument/2006/relationships" id="2147483649" r:id="Rb8e9d20fa8c04b4a"/>
   </p:sldLayoutIdLst>
   <p:txStyles>
     <p:titleStyle>
@@ -1998,7 +2003,7 @@
           <p:cNvPr id="6" name="">
             <a:extLst xmlns:a="http://schemas.openxmlformats.org/drawingml/2006/main">
               <a:ext uri="{FF2B5EF4-FFF2-40B4-BE49-F238E27FC236}">
-                <a16:creationId xmlns:a16="http://schemas.microsoft.com/office/drawing/2014/main" id="{CCE31EA6-BC1C-4579-9E39-618C9D97BCF7}"/>
+                <a16:creationId xmlns:a16="http://schemas.microsoft.com/office/drawing/2014/main" id="{6064292A-8005-4AA1-9B0F-F2E4A29C0E6B}"/>
               </a:ext>
             </a:extLst>
           </p:cNvPr>
@@ -2029,7 +2034,7 @@
           <p:cNvPr id="2" name="">
             <a:extLst xmlns:a="http://schemas.openxmlformats.org/drawingml/2006/main">
               <a:ext uri="{FF2B5EF4-FFF2-40B4-BE49-F238E27FC236}">
-                <a16:creationId xmlns:a16="http://schemas.microsoft.com/office/drawing/2014/main" id="{5700DC92-B292-487D-826B-AF64E069B867}"/>
+                <a16:creationId xmlns:a16="http://schemas.microsoft.com/office/drawing/2014/main" id="{B9709987-F886-4367-B52D-647E40873E5F}"/>
               </a:ext>
             </a:extLst>
           </p:cNvPr>
@@ -2096,7 +2101,7 @@
           <p:cNvPr id="3" name="">
             <a:extLst xmlns:a="http://schemas.openxmlformats.org/drawingml/2006/main">
               <a:ext uri="{FF2B5EF4-FFF2-40B4-BE49-F238E27FC236}">
-                <a16:creationId xmlns:a16="http://schemas.microsoft.com/office/drawing/2014/main" id="{D8BECB7A-7ACE-4FA3-A5AB-62BF214CECB7}"/>
+                <a16:creationId xmlns:a16="http://schemas.microsoft.com/office/drawing/2014/main" id="{067C46C0-635A-4BCC-9886-281294734AC4}"/>
               </a:ext>
             </a:extLst>
           </p:cNvPr>
@@ -2146,7 +2151,7 @@
           <p:cNvPr id="4" name="">
             <a:extLst xmlns:a="http://schemas.openxmlformats.org/drawingml/2006/main">
               <a:ext uri="{FF2B5EF4-FFF2-40B4-BE49-F238E27FC236}">
-                <a16:creationId xmlns:a16="http://schemas.microsoft.com/office/drawing/2014/main" id="{DBBB9E27-C1A8-4ABE-A929-A50D89DB613D}"/>
+                <a16:creationId xmlns:a16="http://schemas.microsoft.com/office/drawing/2014/main" id="{E85208B5-A14A-4EE1-81DC-711962ACF5E8}"/>
               </a:ext>
             </a:extLst>
           </p:cNvPr>
@@ -2196,7 +2201,7 @@
           <p:cNvPr id="5" name="">
             <a:extLst xmlns:a="http://schemas.openxmlformats.org/drawingml/2006/main">
               <a:ext uri="{FF2B5EF4-FFF2-40B4-BE49-F238E27FC236}">
-                <a16:creationId xmlns:a16="http://schemas.microsoft.com/office/drawing/2014/main" id="{8987E6B8-53BA-4F3F-810B-334A4AE042DA}"/>
+                <a16:creationId xmlns:a16="http://schemas.microsoft.com/office/drawing/2014/main" id="{B416E287-80CE-4CB0-9360-8FE802B21B16}"/>
               </a:ext>
             </a:extLst>
           </p:cNvPr>
@@ -2244,7 +2249,7 @@
     </p:spTree>
     <p:extLst>
       <p:ext uri="{BB962C8B-B14F-4D97-AF65-F5344CB8AC3E}">
-        <p14:creationId xmlns:p14="http://schemas.microsoft.com/office/powerpoint/2010/main" val="199636579"/>
+        <p14:creationId xmlns:p14="http://schemas.microsoft.com/office/powerpoint/2010/main" val="1219361829"/>
       </p:ext>
     </p:extLst>
   </p:cSld>
@@ -2275,7 +2280,7 @@
           <p:cNvPr id="9" name="">
             <a:extLst xmlns:a="http://schemas.openxmlformats.org/drawingml/2006/main">
               <a:ext uri="{FF2B5EF4-FFF2-40B4-BE49-F238E27FC236}">
-                <a16:creationId xmlns:a16="http://schemas.microsoft.com/office/drawing/2014/main" id="{B6EEEAC7-7504-488E-8F20-FFD589D807FD}"/>
+                <a16:creationId xmlns:a16="http://schemas.microsoft.com/office/drawing/2014/main" id="{C31D4C27-FF8D-4C9C-AD4D-1CC83B470B1D}"/>
               </a:ext>
             </a:extLst>
           </p:cNvPr>
@@ -2325,7 +2330,7 @@
           <p:cNvPr id="2" name="">
             <a:extLst xmlns:a="http://schemas.openxmlformats.org/drawingml/2006/main">
               <a:ext uri="{FF2B5EF4-FFF2-40B4-BE49-F238E27FC236}">
-                <a16:creationId xmlns:a16="http://schemas.microsoft.com/office/drawing/2014/main" id="{D5A0610B-399E-4B55-B3A6-31FEC5E9C4A8}"/>
+                <a16:creationId xmlns:a16="http://schemas.microsoft.com/office/drawing/2014/main" id="{6C694B90-ED54-4120-ABD1-9525119890F5}"/>
               </a:ext>
             </a:extLst>
           </p:cNvPr>
@@ -2375,7 +2380,7 @@
           <p:cNvPr id="3" name="">
             <a:extLst xmlns:a="http://schemas.openxmlformats.org/drawingml/2006/main">
               <a:ext uri="{FF2B5EF4-FFF2-40B4-BE49-F238E27FC236}">
-                <a16:creationId xmlns:a16="http://schemas.microsoft.com/office/drawing/2014/main" id="{AD19D7D9-79FA-4C6D-93E3-B7C882304739}"/>
+                <a16:creationId xmlns:a16="http://schemas.microsoft.com/office/drawing/2014/main" id="{82E3F12A-3856-4F2A-B3D4-0C6F5A1E7489}"/>
               </a:ext>
             </a:extLst>
           </p:cNvPr>
@@ -2410,7 +2415,7 @@
           <p:nvPr/>
         </p:nvPicPr>
         <p:blipFill>
-          <a:blip xmlns:r="http://schemas.openxmlformats.org/officeDocument/2006/relationships" xmlns:a="http://schemas.openxmlformats.org/drawingml/2006/main" r:embed="R875b826cd3e04269"/>
+          <a:blip xmlns:r="http://schemas.openxmlformats.org/officeDocument/2006/relationships" xmlns:a="http://schemas.openxmlformats.org/drawingml/2006/main" r:embed="Rd6690acb8272443e"/>
           <a:stretch xmlns:a="http://schemas.openxmlformats.org/drawingml/2006/main"/>
         </p:blipFill>
         <p:spPr>
@@ -2428,7 +2433,7 @@
           <p:cNvPr id="5" name="">
             <a:extLst xmlns:a="http://schemas.openxmlformats.org/drawingml/2006/main">
               <a:ext uri="{FF2B5EF4-FFF2-40B4-BE49-F238E27FC236}">
-                <a16:creationId xmlns:a16="http://schemas.microsoft.com/office/drawing/2014/main" id="{F20F0361-DE2D-47B8-B8B1-C8D6D676AAE4}"/>
+                <a16:creationId xmlns:a16="http://schemas.microsoft.com/office/drawing/2014/main" id="{7A4E9023-1491-42CB-AE1C-9C7B02C8D646}"/>
               </a:ext>
             </a:extLst>
           </p:cNvPr>
@@ -2478,7 +2483,7 @@
           <p:cNvPr id="6" name="">
             <a:extLst xmlns:a="http://schemas.openxmlformats.org/drawingml/2006/main">
               <a:ext uri="{FF2B5EF4-FFF2-40B4-BE49-F238E27FC236}">
-                <a16:creationId xmlns:a16="http://schemas.microsoft.com/office/drawing/2014/main" id="{91AA66B3-855F-446F-8854-E26C5D92A423}"/>
+                <a16:creationId xmlns:a16="http://schemas.microsoft.com/office/drawing/2014/main" id="{ABE9D428-7DC2-486B-9343-1C20B2994EC9}"/>
               </a:ext>
             </a:extLst>
           </p:cNvPr>
@@ -2528,7 +2533,7 @@
           <p:cNvPr id="7" name="">
             <a:extLst xmlns:a="http://schemas.openxmlformats.org/drawingml/2006/main">
               <a:ext uri="{FF2B5EF4-FFF2-40B4-BE49-F238E27FC236}">
-                <a16:creationId xmlns:a16="http://schemas.microsoft.com/office/drawing/2014/main" id="{54367D81-D5D0-47F0-BCD5-9E6BCD745165}"/>
+                <a16:creationId xmlns:a16="http://schemas.microsoft.com/office/drawing/2014/main" id="{D61C2891-2715-4770-A6FB-C3CB4A234E7C}"/>
               </a:ext>
             </a:extLst>
           </p:cNvPr>
@@ -2578,7 +2583,7 @@
           <p:cNvPr id="8" name="">
             <a:extLst xmlns:a="http://schemas.openxmlformats.org/drawingml/2006/main">
               <a:ext uri="{FF2B5EF4-FFF2-40B4-BE49-F238E27FC236}">
-                <a16:creationId xmlns:a16="http://schemas.microsoft.com/office/drawing/2014/main" id="{0CC8BD46-8F3E-4E4B-9E17-F9D68DC0E086}"/>
+                <a16:creationId xmlns:a16="http://schemas.microsoft.com/office/drawing/2014/main" id="{C4D1DB81-3D4A-4631-BACF-FA0F42087B20}"/>
               </a:ext>
             </a:extLst>
           </p:cNvPr>
@@ -2626,7 +2631,7 @@
     </p:spTree>
     <p:extLst>
       <p:ext uri="{BB962C8B-B14F-4D97-AF65-F5344CB8AC3E}">
-        <p14:creationId xmlns:p14="http://schemas.microsoft.com/office/powerpoint/2010/main" val="863903274"/>
+        <p14:creationId xmlns:p14="http://schemas.microsoft.com/office/powerpoint/2010/main" val="1662233653"/>
       </p:ext>
     </p:extLst>
   </p:cSld>
@@ -2657,7 +2662,7 @@
           <p:cNvPr id="23" name="">
             <a:extLst xmlns:a="http://schemas.openxmlformats.org/drawingml/2006/main">
               <a:ext uri="{FF2B5EF4-FFF2-40B4-BE49-F238E27FC236}">
-                <a16:creationId xmlns:a16="http://schemas.microsoft.com/office/drawing/2014/main" id="{5329D6D4-A622-461A-8581-0D6CF8C1B40A}"/>
+                <a16:creationId xmlns:a16="http://schemas.microsoft.com/office/drawing/2014/main" id="{CF5A378F-4ADF-4D1B-AE2F-AA9EE9D13650}"/>
               </a:ext>
             </a:extLst>
           </p:cNvPr>
@@ -2707,7 +2712,7 @@
           <p:cNvPr id="2" name="">
             <a:extLst xmlns:a="http://schemas.openxmlformats.org/drawingml/2006/main">
               <a:ext uri="{FF2B5EF4-FFF2-40B4-BE49-F238E27FC236}">
-                <a16:creationId xmlns:a16="http://schemas.microsoft.com/office/drawing/2014/main" id="{2707525C-8795-48C2-9A5B-03AA9AA6E847}"/>
+                <a16:creationId xmlns:a16="http://schemas.microsoft.com/office/drawing/2014/main" id="{A51BCCCF-F093-428E-B5E7-F90C103C5804}"/>
               </a:ext>
             </a:extLst>
           </p:cNvPr>
@@ -2757,7 +2762,7 @@
           <p:cNvPr id="3" name="">
             <a:extLst xmlns:a="http://schemas.openxmlformats.org/drawingml/2006/main">
               <a:ext uri="{FF2B5EF4-FFF2-40B4-BE49-F238E27FC236}">
-                <a16:creationId xmlns:a16="http://schemas.microsoft.com/office/drawing/2014/main" id="{D8A87D31-DEF9-44F6-9E93-486BB92F2CA1}"/>
+                <a16:creationId xmlns:a16="http://schemas.microsoft.com/office/drawing/2014/main" id="{3AD9761A-AED0-4510-BC46-291FCD687FFA}"/>
               </a:ext>
             </a:extLst>
           </p:cNvPr>
@@ -2788,7 +2793,7 @@
           <p:cNvPr id="4" name="">
             <a:extLst xmlns:a="http://schemas.openxmlformats.org/drawingml/2006/main">
               <a:ext uri="{FF2B5EF4-FFF2-40B4-BE49-F238E27FC236}">
-                <a16:creationId xmlns:a16="http://schemas.microsoft.com/office/drawing/2014/main" id="{F77D7705-D2CA-4B5A-A796-9691E30F6422}"/>
+                <a16:creationId xmlns:a16="http://schemas.microsoft.com/office/drawing/2014/main" id="{86192D8C-31A9-4FE8-B033-76BBA711FC01}"/>
               </a:ext>
             </a:extLst>
           </p:cNvPr>
@@ -2838,7 +2843,7 @@
           <p:cNvPr id="5" name="">
             <a:extLst xmlns:a="http://schemas.openxmlformats.org/drawingml/2006/main">
               <a:ext uri="{FF2B5EF4-FFF2-40B4-BE49-F238E27FC236}">
-                <a16:creationId xmlns:a16="http://schemas.microsoft.com/office/drawing/2014/main" id="{1A80EA4C-5759-4945-B293-6D8A32499164}"/>
+                <a16:creationId xmlns:a16="http://schemas.microsoft.com/office/drawing/2014/main" id="{2BC5EFD5-EF1D-4149-877C-FB89FEF609C4}"/>
               </a:ext>
             </a:extLst>
           </p:cNvPr>
@@ -2888,7 +2893,7 @@
           <p:cNvPr id="6" name="">
             <a:extLst xmlns:a="http://schemas.openxmlformats.org/drawingml/2006/main">
               <a:ext uri="{FF2B5EF4-FFF2-40B4-BE49-F238E27FC236}">
-                <a16:creationId xmlns:a16="http://schemas.microsoft.com/office/drawing/2014/main" id="{BDE0478D-37C5-4DD6-9BA1-C18ADAB15BF8}"/>
+                <a16:creationId xmlns:a16="http://schemas.microsoft.com/office/drawing/2014/main" id="{4FF816F0-D5D0-4420-95B6-2A21EDBCD46B}"/>
               </a:ext>
             </a:extLst>
           </p:cNvPr>
@@ -2938,7 +2943,7 @@
           <p:cNvPr id="7" name="">
             <a:extLst xmlns:a="http://schemas.openxmlformats.org/drawingml/2006/main">
               <a:ext uri="{FF2B5EF4-FFF2-40B4-BE49-F238E27FC236}">
-                <a16:creationId xmlns:a16="http://schemas.microsoft.com/office/drawing/2014/main" id="{9A22D0F6-DBF2-4A20-8581-2ADCE293570A}"/>
+                <a16:creationId xmlns:a16="http://schemas.microsoft.com/office/drawing/2014/main" id="{AFA130B9-F5AF-4A8E-B390-B8E06BAEA87C}"/>
               </a:ext>
             </a:extLst>
           </p:cNvPr>
@@ -2969,7 +2974,7 @@
           <p:cNvPr id="8" name="">
             <a:extLst xmlns:a="http://schemas.openxmlformats.org/drawingml/2006/main">
               <a:ext uri="{FF2B5EF4-FFF2-40B4-BE49-F238E27FC236}">
-                <a16:creationId xmlns:a16="http://schemas.microsoft.com/office/drawing/2014/main" id="{A4C75D21-B8DE-4647-A40A-D38B4A836496}"/>
+                <a16:creationId xmlns:a16="http://schemas.microsoft.com/office/drawing/2014/main" id="{B0360D0D-66F4-4429-9D61-316BB843A732}"/>
               </a:ext>
             </a:extLst>
           </p:cNvPr>
@@ -3019,7 +3024,7 @@
           <p:cNvPr id="9" name="">
             <a:extLst xmlns:a="http://schemas.openxmlformats.org/drawingml/2006/main">
               <a:ext uri="{FF2B5EF4-FFF2-40B4-BE49-F238E27FC236}">
-                <a16:creationId xmlns:a16="http://schemas.microsoft.com/office/drawing/2014/main" id="{D1F4260F-FD39-4459-A2F4-020B39563C05}"/>
+                <a16:creationId xmlns:a16="http://schemas.microsoft.com/office/drawing/2014/main" id="{77DEA4C1-6106-4F1D-9DEE-BDF73291E685}"/>
               </a:ext>
             </a:extLst>
           </p:cNvPr>
@@ -3069,7 +3074,7 @@
           <p:cNvPr id="10" name="">
             <a:extLst xmlns:a="http://schemas.openxmlformats.org/drawingml/2006/main">
               <a:ext uri="{FF2B5EF4-FFF2-40B4-BE49-F238E27FC236}">
-                <a16:creationId xmlns:a16="http://schemas.microsoft.com/office/drawing/2014/main" id="{06FF2E01-3654-4B5A-B1BE-2B3D6B240FEC}"/>
+                <a16:creationId xmlns:a16="http://schemas.microsoft.com/office/drawing/2014/main" id="{DCC91FEF-8B14-4B89-B043-213FABC8F7DA}"/>
               </a:ext>
             </a:extLst>
           </p:cNvPr>
@@ -3119,7 +3124,7 @@
           <p:cNvPr id="11" name="">
             <a:extLst xmlns:a="http://schemas.openxmlformats.org/drawingml/2006/main">
               <a:ext uri="{FF2B5EF4-FFF2-40B4-BE49-F238E27FC236}">
-                <a16:creationId xmlns:a16="http://schemas.microsoft.com/office/drawing/2014/main" id="{789AF8F4-116B-4E0B-82EB-BF3A084D68FA}"/>
+                <a16:creationId xmlns:a16="http://schemas.microsoft.com/office/drawing/2014/main" id="{696C3B2D-A767-4C9D-9F4F-8627E3235D62}"/>
               </a:ext>
             </a:extLst>
           </p:cNvPr>
@@ -3169,7 +3174,7 @@
           <p:cNvPr id="12" name="">
             <a:extLst xmlns:a="http://schemas.openxmlformats.org/drawingml/2006/main">
               <a:ext uri="{FF2B5EF4-FFF2-40B4-BE49-F238E27FC236}">
-                <a16:creationId xmlns:a16="http://schemas.microsoft.com/office/drawing/2014/main" id="{CCF5527E-EB14-4157-8C65-525FA511137E}"/>
+                <a16:creationId xmlns:a16="http://schemas.microsoft.com/office/drawing/2014/main" id="{1487E774-0B05-4B9F-A7AB-1F175FCF53D3}"/>
               </a:ext>
             </a:extLst>
           </p:cNvPr>
@@ -3219,7 +3224,7 @@
           <p:cNvPr id="13" name="">
             <a:extLst xmlns:a="http://schemas.openxmlformats.org/drawingml/2006/main">
               <a:ext uri="{FF2B5EF4-FFF2-40B4-BE49-F238E27FC236}">
-                <a16:creationId xmlns:a16="http://schemas.microsoft.com/office/drawing/2014/main" id="{79F065AB-56C5-410D-A4A9-5722943919A0}"/>
+                <a16:creationId xmlns:a16="http://schemas.microsoft.com/office/drawing/2014/main" id="{F3D25DA4-72D6-4AAA-B76A-609E07F73E23}"/>
               </a:ext>
             </a:extLst>
           </p:cNvPr>
@@ -3269,7 +3274,7 @@
           <p:cNvPr id="14" name="">
             <a:extLst xmlns:a="http://schemas.openxmlformats.org/drawingml/2006/main">
               <a:ext uri="{FF2B5EF4-FFF2-40B4-BE49-F238E27FC236}">
-                <a16:creationId xmlns:a16="http://schemas.microsoft.com/office/drawing/2014/main" id="{615B67BF-1571-4A81-BF2A-ABE9363AF04D}"/>
+                <a16:creationId xmlns:a16="http://schemas.microsoft.com/office/drawing/2014/main" id="{6858067B-9E67-47EB-9BC7-6EC31B18C4F3}"/>
               </a:ext>
             </a:extLst>
           </p:cNvPr>
@@ -3300,7 +3305,7 @@
           <p:cNvPr id="15" name="">
             <a:extLst xmlns:a="http://schemas.openxmlformats.org/drawingml/2006/main">
               <a:ext uri="{FF2B5EF4-FFF2-40B4-BE49-F238E27FC236}">
-                <a16:creationId xmlns:a16="http://schemas.microsoft.com/office/drawing/2014/main" id="{AAC5974E-5170-43A7-8AD2-9308DE8AF079}"/>
+                <a16:creationId xmlns:a16="http://schemas.microsoft.com/office/drawing/2014/main" id="{3FE03789-5662-48A4-8F11-D15D6BD16131}"/>
               </a:ext>
             </a:extLst>
           </p:cNvPr>
@@ -3350,7 +3355,7 @@
           <p:cNvPr id="16" name="">
             <a:extLst xmlns:a="http://schemas.openxmlformats.org/drawingml/2006/main">
               <a:ext uri="{FF2B5EF4-FFF2-40B4-BE49-F238E27FC236}">
-                <a16:creationId xmlns:a16="http://schemas.microsoft.com/office/drawing/2014/main" id="{6CD49FB9-89F2-4D3F-B255-A3F81C4478DA}"/>
+                <a16:creationId xmlns:a16="http://schemas.microsoft.com/office/drawing/2014/main" id="{2B0F25A2-CEED-4586-8391-B9F046D251DC}"/>
               </a:ext>
             </a:extLst>
           </p:cNvPr>
@@ -3400,7 +3405,7 @@
           <p:cNvPr id="17" name="">
             <a:extLst xmlns:a="http://schemas.openxmlformats.org/drawingml/2006/main">
               <a:ext uri="{FF2B5EF4-FFF2-40B4-BE49-F238E27FC236}">
-                <a16:creationId xmlns:a16="http://schemas.microsoft.com/office/drawing/2014/main" id="{FEE03377-EB64-4F25-936E-DB42270E2E42}"/>
+                <a16:creationId xmlns:a16="http://schemas.microsoft.com/office/drawing/2014/main" id="{3988E9FB-9788-45E3-8394-A22F90597229}"/>
               </a:ext>
             </a:extLst>
           </p:cNvPr>
@@ -3450,7 +3455,7 @@
           <p:cNvPr id="18" name="">
             <a:extLst xmlns:a="http://schemas.openxmlformats.org/drawingml/2006/main">
               <a:ext uri="{FF2B5EF4-FFF2-40B4-BE49-F238E27FC236}">
-                <a16:creationId xmlns:a16="http://schemas.microsoft.com/office/drawing/2014/main" id="{B5ADE2BD-2505-4843-B518-9BD37EA78D34}"/>
+                <a16:creationId xmlns:a16="http://schemas.microsoft.com/office/drawing/2014/main" id="{EB72539E-59C2-43E0-9BD0-EF3E17935C05}"/>
               </a:ext>
             </a:extLst>
           </p:cNvPr>
@@ -3500,7 +3505,7 @@
           <p:cNvPr id="19" name="">
             <a:extLst xmlns:a="http://schemas.openxmlformats.org/drawingml/2006/main">
               <a:ext uri="{FF2B5EF4-FFF2-40B4-BE49-F238E27FC236}">
-                <a16:creationId xmlns:a16="http://schemas.microsoft.com/office/drawing/2014/main" id="{32F9736D-2A9E-418B-A3CD-BE08AE5E0E8F}"/>
+                <a16:creationId xmlns:a16="http://schemas.microsoft.com/office/drawing/2014/main" id="{F997339F-9615-411C-802E-007C6F28B54E}"/>
               </a:ext>
             </a:extLst>
           </p:cNvPr>
@@ -3550,7 +3555,7 @@
           <p:cNvPr id="20" name="">
             <a:extLst xmlns:a="http://schemas.openxmlformats.org/drawingml/2006/main">
               <a:ext uri="{FF2B5EF4-FFF2-40B4-BE49-F238E27FC236}">
-                <a16:creationId xmlns:a16="http://schemas.microsoft.com/office/drawing/2014/main" id="{54A9D41F-4685-4C7B-B39C-DE6664363282}"/>
+                <a16:creationId xmlns:a16="http://schemas.microsoft.com/office/drawing/2014/main" id="{92622B66-F99E-4944-B703-292988D7C697}"/>
               </a:ext>
             </a:extLst>
           </p:cNvPr>
@@ -3604,7 +3609,7 @@
           <p:nvPr/>
         </p:nvPicPr>
         <p:blipFill>
-          <a:blip xmlns:r="http://schemas.openxmlformats.org/officeDocument/2006/relationships" xmlns:a="http://schemas.openxmlformats.org/drawingml/2006/main" r:embed="R6d36178579b34d47"/>
+          <a:blip xmlns:r="http://schemas.openxmlformats.org/officeDocument/2006/relationships" xmlns:a="http://schemas.openxmlformats.org/drawingml/2006/main" r:embed="R00b7ad0564c0433d"/>
           <a:stretch xmlns:a="http://schemas.openxmlformats.org/drawingml/2006/main"/>
         </p:blipFill>
         <p:spPr>
@@ -3622,7 +3627,7 @@
           <p:cNvPr id="22" name="">
             <a:extLst xmlns:a="http://schemas.openxmlformats.org/drawingml/2006/main">
               <a:ext uri="{FF2B5EF4-FFF2-40B4-BE49-F238E27FC236}">
-                <a16:creationId xmlns:a16="http://schemas.microsoft.com/office/drawing/2014/main" id="{7809E840-3A5A-4D47-B0E0-DC932FB7FF4E}"/>
+                <a16:creationId xmlns:a16="http://schemas.microsoft.com/office/drawing/2014/main" id="{4FDA8CBC-661D-4B2A-ADBF-FCDA137DFAF8}"/>
               </a:ext>
             </a:extLst>
           </p:cNvPr>
@@ -3670,7 +3675,7 @@
     </p:spTree>
     <p:extLst>
       <p:ext uri="{BB962C8B-B14F-4D97-AF65-F5344CB8AC3E}">
-        <p14:creationId xmlns:p14="http://schemas.microsoft.com/office/powerpoint/2010/main" val="1365903264"/>
+        <p14:creationId xmlns:p14="http://schemas.microsoft.com/office/powerpoint/2010/main" val="1776707102"/>
       </p:ext>
     </p:extLst>
   </p:cSld>
@@ -3701,7 +3706,7 @@
           <p:cNvPr id="16" name="">
             <a:extLst xmlns:a="http://schemas.openxmlformats.org/drawingml/2006/main">
               <a:ext uri="{FF2B5EF4-FFF2-40B4-BE49-F238E27FC236}">
-                <a16:creationId xmlns:a16="http://schemas.microsoft.com/office/drawing/2014/main" id="{AD38E86C-3690-4BEB-95EB-57FB4C9622FC}"/>
+                <a16:creationId xmlns:a16="http://schemas.microsoft.com/office/drawing/2014/main" id="{8A149933-D387-428F-B3AB-58CF511372AA}"/>
               </a:ext>
             </a:extLst>
           </p:cNvPr>
@@ -3751,7 +3756,7 @@
           <p:cNvPr id="2" name="">
             <a:extLst xmlns:a="http://schemas.openxmlformats.org/drawingml/2006/main">
               <a:ext uri="{FF2B5EF4-FFF2-40B4-BE49-F238E27FC236}">
-                <a16:creationId xmlns:a16="http://schemas.microsoft.com/office/drawing/2014/main" id="{631A289E-B78E-4770-B61D-176E912BE224}"/>
+                <a16:creationId xmlns:a16="http://schemas.microsoft.com/office/drawing/2014/main" id="{FB957F45-B2DF-4D56-9E53-1CA7FDC811B3}"/>
               </a:ext>
             </a:extLst>
           </p:cNvPr>
@@ -3801,7 +3806,7 @@
           <p:cNvPr id="3" name="">
             <a:extLst xmlns:a="http://schemas.openxmlformats.org/drawingml/2006/main">
               <a:ext uri="{FF2B5EF4-FFF2-40B4-BE49-F238E27FC236}">
-                <a16:creationId xmlns:a16="http://schemas.microsoft.com/office/drawing/2014/main" id="{F522CD07-24B1-491E-80E6-9344EC227113}"/>
+                <a16:creationId xmlns:a16="http://schemas.microsoft.com/office/drawing/2014/main" id="{B70604BD-207E-4BDE-BEB6-276669E194DF}"/>
               </a:ext>
             </a:extLst>
           </p:cNvPr>
@@ -3832,7 +3837,7 @@
           <p:cNvPr id="4" name="">
             <a:extLst xmlns:a="http://schemas.openxmlformats.org/drawingml/2006/main">
               <a:ext uri="{FF2B5EF4-FFF2-40B4-BE49-F238E27FC236}">
-                <a16:creationId xmlns:a16="http://schemas.microsoft.com/office/drawing/2014/main" id="{05EE6E77-DF8B-4B5A-AA97-F3869761B135}"/>
+                <a16:creationId xmlns:a16="http://schemas.microsoft.com/office/drawing/2014/main" id="{44AF0B28-761F-4A25-8E33-C051C9A8042C}"/>
               </a:ext>
             </a:extLst>
           </p:cNvPr>
@@ -3882,7 +3887,7 @@
           <p:cNvPr id="5" name="">
             <a:extLst xmlns:a="http://schemas.openxmlformats.org/drawingml/2006/main">
               <a:ext uri="{FF2B5EF4-FFF2-40B4-BE49-F238E27FC236}">
-                <a16:creationId xmlns:a16="http://schemas.microsoft.com/office/drawing/2014/main" id="{0C830673-C2DE-4837-A8AD-3500DB467B56}"/>
+                <a16:creationId xmlns:a16="http://schemas.microsoft.com/office/drawing/2014/main" id="{E786DFB7-8223-404E-B74B-82E3DD2A5544}"/>
               </a:ext>
             </a:extLst>
           </p:cNvPr>
@@ -3932,7 +3937,7 @@
           <p:cNvPr id="6" name="">
             <a:extLst xmlns:a="http://schemas.openxmlformats.org/drawingml/2006/main">
               <a:ext uri="{FF2B5EF4-FFF2-40B4-BE49-F238E27FC236}">
-                <a16:creationId xmlns:a16="http://schemas.microsoft.com/office/drawing/2014/main" id="{68F0CA72-A853-4B35-92A2-7171B1862DBE}"/>
+                <a16:creationId xmlns:a16="http://schemas.microsoft.com/office/drawing/2014/main" id="{C8AEA42B-05C2-431D-A232-24C295BD1D31}"/>
               </a:ext>
             </a:extLst>
           </p:cNvPr>
@@ -3982,7 +3987,7 @@
           <p:cNvPr id="7" name="">
             <a:extLst xmlns:a="http://schemas.openxmlformats.org/drawingml/2006/main">
               <a:ext uri="{FF2B5EF4-FFF2-40B4-BE49-F238E27FC236}">
-                <a16:creationId xmlns:a16="http://schemas.microsoft.com/office/drawing/2014/main" id="{F0F7944F-A9FB-4D36-8D61-93FEAD1DF035}"/>
+                <a16:creationId xmlns:a16="http://schemas.microsoft.com/office/drawing/2014/main" id="{4A740356-6FEA-4055-8E23-E7C4DDF47058}"/>
               </a:ext>
             </a:extLst>
           </p:cNvPr>
@@ -4032,7 +4037,7 @@
           <p:cNvPr id="8" name="">
             <a:extLst xmlns:a="http://schemas.openxmlformats.org/drawingml/2006/main">
               <a:ext uri="{FF2B5EF4-FFF2-40B4-BE49-F238E27FC236}">
-                <a16:creationId xmlns:a16="http://schemas.microsoft.com/office/drawing/2014/main" id="{C09626BD-FA3E-4703-A6B2-64B2BF8B3077}"/>
+                <a16:creationId xmlns:a16="http://schemas.microsoft.com/office/drawing/2014/main" id="{0B3EF793-066E-4FFE-9F8E-1C64EB72FDBB}"/>
               </a:ext>
             </a:extLst>
           </p:cNvPr>
@@ -4082,7 +4087,7 @@
           <p:cNvPr id="9" name="">
             <a:extLst xmlns:a="http://schemas.openxmlformats.org/drawingml/2006/main">
               <a:ext uri="{FF2B5EF4-FFF2-40B4-BE49-F238E27FC236}">
-                <a16:creationId xmlns:a16="http://schemas.microsoft.com/office/drawing/2014/main" id="{9280B22C-CB3E-407D-86A2-326086018113}"/>
+                <a16:creationId xmlns:a16="http://schemas.microsoft.com/office/drawing/2014/main" id="{7FD8BC04-7849-4E09-A54A-1DCF74AC8CB2}"/>
               </a:ext>
             </a:extLst>
           </p:cNvPr>
@@ -4132,7 +4137,7 @@
           <p:cNvPr id="10" name="">
             <a:extLst xmlns:a="http://schemas.openxmlformats.org/drawingml/2006/main">
               <a:ext uri="{FF2B5EF4-FFF2-40B4-BE49-F238E27FC236}">
-                <a16:creationId xmlns:a16="http://schemas.microsoft.com/office/drawing/2014/main" id="{1DE2DB48-1E26-4669-B086-8B9A7DAC11D7}"/>
+                <a16:creationId xmlns:a16="http://schemas.microsoft.com/office/drawing/2014/main" id="{CB9256F4-1AAE-4A8D-8BD1-379935CCF740}"/>
               </a:ext>
             </a:extLst>
           </p:cNvPr>
@@ -4182,7 +4187,7 @@
           <p:cNvPr id="11" name="">
             <a:extLst xmlns:a="http://schemas.openxmlformats.org/drawingml/2006/main">
               <a:ext uri="{FF2B5EF4-FFF2-40B4-BE49-F238E27FC236}">
-                <a16:creationId xmlns:a16="http://schemas.microsoft.com/office/drawing/2014/main" id="{79D7CDE9-55E2-46D4-97BC-72D6ABD6A43D}"/>
+                <a16:creationId xmlns:a16="http://schemas.microsoft.com/office/drawing/2014/main" id="{1D55E176-0D9D-45A2-98DC-B020052FB52A}"/>
               </a:ext>
             </a:extLst>
           </p:cNvPr>
@@ -4232,7 +4237,7 @@
           <p:cNvPr id="12" name="">
             <a:extLst xmlns:a="http://schemas.openxmlformats.org/drawingml/2006/main">
               <a:ext uri="{FF2B5EF4-FFF2-40B4-BE49-F238E27FC236}">
-                <a16:creationId xmlns:a16="http://schemas.microsoft.com/office/drawing/2014/main" id="{04E08990-9A12-4942-B8DA-CF94BE028327}"/>
+                <a16:creationId xmlns:a16="http://schemas.microsoft.com/office/drawing/2014/main" id="{E6149303-7572-49F4-B906-EF53A0D6EA0A}"/>
               </a:ext>
             </a:extLst>
           </p:cNvPr>
@@ -4282,7 +4287,7 @@
           <p:cNvPr id="13" name="">
             <a:extLst xmlns:a="http://schemas.openxmlformats.org/drawingml/2006/main">
               <a:ext uri="{FF2B5EF4-FFF2-40B4-BE49-F238E27FC236}">
-                <a16:creationId xmlns:a16="http://schemas.microsoft.com/office/drawing/2014/main" id="{43DC06CC-3C7F-4025-91A2-44448E9FF7B4}"/>
+                <a16:creationId xmlns:a16="http://schemas.microsoft.com/office/drawing/2014/main" id="{873879F6-449E-4535-92E1-D2837B2C630D}"/>
               </a:ext>
             </a:extLst>
           </p:cNvPr>
@@ -4332,7 +4337,7 @@
           <p:cNvPr id="14" name="">
             <a:extLst xmlns:a="http://schemas.openxmlformats.org/drawingml/2006/main">
               <a:ext uri="{FF2B5EF4-FFF2-40B4-BE49-F238E27FC236}">
-                <a16:creationId xmlns:a16="http://schemas.microsoft.com/office/drawing/2014/main" id="{007C7D13-74E8-4F87-B140-918DBA16EEF0}"/>
+                <a16:creationId xmlns:a16="http://schemas.microsoft.com/office/drawing/2014/main" id="{1464E9B1-CACA-4358-B2A2-8F02536FEC78}"/>
               </a:ext>
             </a:extLst>
           </p:cNvPr>
@@ -4382,7 +4387,7 @@
           <p:cNvPr id="15" name="">
             <a:extLst xmlns:a="http://schemas.openxmlformats.org/drawingml/2006/main">
               <a:ext uri="{FF2B5EF4-FFF2-40B4-BE49-F238E27FC236}">
-                <a16:creationId xmlns:a16="http://schemas.microsoft.com/office/drawing/2014/main" id="{4AD41170-FC86-4AA3-8449-07DE0D9046C6}"/>
+                <a16:creationId xmlns:a16="http://schemas.microsoft.com/office/drawing/2014/main" id="{DC02A90A-329F-4097-BA2C-47EE67CD8B9F}"/>
               </a:ext>
             </a:extLst>
           </p:cNvPr>
@@ -4430,7 +4435,7 @@
     </p:spTree>
     <p:extLst>
       <p:ext uri="{BB962C8B-B14F-4D97-AF65-F5344CB8AC3E}">
-        <p14:creationId xmlns:p14="http://schemas.microsoft.com/office/powerpoint/2010/main" val="1426569069"/>
+        <p14:creationId xmlns:p14="http://schemas.microsoft.com/office/powerpoint/2010/main" val="702832965"/>
       </p:ext>
     </p:extLst>
   </p:cSld>
@@ -4461,7 +4466,7 @@
           <p:cNvPr id="10" name="">
             <a:extLst xmlns:a="http://schemas.openxmlformats.org/drawingml/2006/main">
               <a:ext uri="{FF2B5EF4-FFF2-40B4-BE49-F238E27FC236}">
-                <a16:creationId xmlns:a16="http://schemas.microsoft.com/office/drawing/2014/main" id="{599031DC-305B-4B10-9965-CE19DF284B92}"/>
+                <a16:creationId xmlns:a16="http://schemas.microsoft.com/office/drawing/2014/main" id="{BBC7DA93-B017-46D4-A49F-51DCD76200B2}"/>
               </a:ext>
             </a:extLst>
           </p:cNvPr>
@@ -4511,7 +4516,7 @@
           <p:cNvPr id="2" name="">
             <a:extLst xmlns:a="http://schemas.openxmlformats.org/drawingml/2006/main">
               <a:ext uri="{FF2B5EF4-FFF2-40B4-BE49-F238E27FC236}">
-                <a16:creationId xmlns:a16="http://schemas.microsoft.com/office/drawing/2014/main" id="{A39EA161-E7B3-46C6-B8DB-AE1F7B1A14EF}"/>
+                <a16:creationId xmlns:a16="http://schemas.microsoft.com/office/drawing/2014/main" id="{CE107869-FC08-4496-BBAA-DB470AC2236E}"/>
               </a:ext>
             </a:extLst>
           </p:cNvPr>
@@ -4561,7 +4566,7 @@
           <p:cNvPr id="3" name="">
             <a:extLst xmlns:a="http://schemas.openxmlformats.org/drawingml/2006/main">
               <a:ext uri="{FF2B5EF4-FFF2-40B4-BE49-F238E27FC236}">
-                <a16:creationId xmlns:a16="http://schemas.microsoft.com/office/drawing/2014/main" id="{2DF35DCD-395B-4B53-84F6-7F02F11C9FBB}"/>
+                <a16:creationId xmlns:a16="http://schemas.microsoft.com/office/drawing/2014/main" id="{EE6F3DAE-AF7A-4273-94A7-96A5BC239C07}"/>
               </a:ext>
             </a:extLst>
           </p:cNvPr>
@@ -4592,7 +4597,7 @@
           <p:cNvPr id="4" name="">
             <a:extLst xmlns:a="http://schemas.openxmlformats.org/drawingml/2006/main">
               <a:ext uri="{FF2B5EF4-FFF2-40B4-BE49-F238E27FC236}">
-                <a16:creationId xmlns:a16="http://schemas.microsoft.com/office/drawing/2014/main" id="{29DE1CB3-4395-4EF8-9AFE-F29E7E06ED30}"/>
+                <a16:creationId xmlns:a16="http://schemas.microsoft.com/office/drawing/2014/main" id="{79A5DA9B-0B58-4BFD-B327-FE7659D345D3}"/>
               </a:ext>
             </a:extLst>
           </p:cNvPr>
@@ -4642,7 +4647,7 @@
           <p:cNvPr id="5" name="">
             <a:extLst xmlns:a="http://schemas.openxmlformats.org/drawingml/2006/main">
               <a:ext uri="{FF2B5EF4-FFF2-40B4-BE49-F238E27FC236}">
-                <a16:creationId xmlns:a16="http://schemas.microsoft.com/office/drawing/2014/main" id="{97C8F8B4-91FE-4EAA-8312-970F22DF605D}"/>
+                <a16:creationId xmlns:a16="http://schemas.microsoft.com/office/drawing/2014/main" id="{BFB70F71-EEAF-405E-96C1-F63E034753DA}"/>
               </a:ext>
             </a:extLst>
           </p:cNvPr>
@@ -4811,7 +4816,7 @@
           <p:cNvPr id="6" name="">
             <a:extLst xmlns:a="http://schemas.openxmlformats.org/drawingml/2006/main">
               <a:ext uri="{FF2B5EF4-FFF2-40B4-BE49-F238E27FC236}">
-                <a16:creationId xmlns:a16="http://schemas.microsoft.com/office/drawing/2014/main" id="{7363E25C-AB4C-4A1F-ACBD-14B21594D19B}"/>
+                <a16:creationId xmlns:a16="http://schemas.microsoft.com/office/drawing/2014/main" id="{C2CACC08-263B-44C1-8C3F-C1B86F2210C6}"/>
               </a:ext>
             </a:extLst>
           </p:cNvPr>
@@ -4842,7 +4847,7 @@
           <p:cNvPr id="7" name="">
             <a:extLst xmlns:a="http://schemas.openxmlformats.org/drawingml/2006/main">
               <a:ext uri="{FF2B5EF4-FFF2-40B4-BE49-F238E27FC236}">
-                <a16:creationId xmlns:a16="http://schemas.microsoft.com/office/drawing/2014/main" id="{234985B8-6917-4828-A2CA-3651A332EC93}"/>
+                <a16:creationId xmlns:a16="http://schemas.microsoft.com/office/drawing/2014/main" id="{F05B0645-A56F-4CDE-B5E6-AED6733DA1E7}"/>
               </a:ext>
             </a:extLst>
           </p:cNvPr>
@@ -4882,7 +4887,7 @@
                   <a:srgbClr val="111111"/>
                 </a:solidFill>
               </a:rPr>
-              <a:t>Before uploading</a:t>
+              <a:t>Public GitHub repository</a:t>
             </a:r>
           </a:p>
         </p:txBody>
@@ -4892,7 +4897,7 @@
           <p:cNvPr id="8" name="">
             <a:extLst xmlns:a="http://schemas.openxmlformats.org/drawingml/2006/main">
               <a:ext uri="{FF2B5EF4-FFF2-40B4-BE49-F238E27FC236}">
-                <a16:creationId xmlns:a16="http://schemas.microsoft.com/office/drawing/2014/main" id="{A6EE53F0-9DFE-41DC-AE8F-C69B17F76720}"/>
+                <a16:creationId xmlns:a16="http://schemas.microsoft.com/office/drawing/2014/main" id="{4E716D14-39F4-4EB6-916F-02EADA285350}"/>
               </a:ext>
             </a:extLst>
           </p:cNvPr>
@@ -4904,7 +4909,7 @@
         <p:spPr>
           <a:xfrm xmlns:a="http://schemas.openxmlformats.org/drawingml/2006/main">
             <a:off x="6524625" y="2381250"/>
-            <a:ext cx="4381500" cy="1285875"/>
+            <a:ext cx="4381500" cy="1095375"/>
           </a:xfrm>
           <a:prstGeom xmlns:a="http://schemas.openxmlformats.org/drawingml/2006/main" prst="rect">
             <a:avLst/>
@@ -4932,7 +4937,7 @@
                   <a:srgbClr val="111111"/>
                 </a:solidFill>
               </a:rPr>
-              <a:t>Add your GitHub repository URL to this slide and confirm every notebook is committed. Export this presentation to PDF for peer review.</a:t>
+              <a:t>All completed notebooks, dashboard code, screenshots, map, presentation, and report are available in the repository.</a:t>
             </a:r>
           </a:p>
         </p:txBody>
@@ -4942,47 +4947,47 @@
           <p:cNvPr id="9" name="">
             <a:extLst xmlns:a="http://schemas.openxmlformats.org/drawingml/2006/main">
               <a:ext uri="{FF2B5EF4-FFF2-40B4-BE49-F238E27FC236}">
-                <a16:creationId xmlns:a16="http://schemas.microsoft.com/office/drawing/2014/main" id="{41807C3C-1F1F-4A66-87F7-52FD58DB5672}"/>
-              </a:ext>
-            </a:extLst>
-          </p:cNvPr>
-          <p:cNvSpPr>
-            <a:spLocks xmlns:a="http://schemas.openxmlformats.org/drawingml/2006/main" noGrp="1"/>
-          </p:cNvSpPr>
-          <p:nvPr/>
-        </p:nvSpPr>
-        <p:spPr>
-          <a:xfrm xmlns:a="http://schemas.openxmlformats.org/drawingml/2006/main">
-            <a:off x="6524625" y="3952875"/>
-            <a:ext cx="4381500" cy="381000"/>
-          </a:xfrm>
-          <a:prstGeom xmlns:a="http://schemas.openxmlformats.org/drawingml/2006/main" prst="rect">
-            <a:avLst/>
-          </a:prstGeom>
-          <a:noFill xmlns:a="http://schemas.openxmlformats.org/drawingml/2006/main"/>
-          <a:ln xmlns:a="http://schemas.openxmlformats.org/drawingml/2006/main" w="0">
-            <a:noFill/>
-            <a:prstDash val="solid"/>
-          </a:ln>
-        </p:spPr>
-        <p:txBody>
-          <a:bodyPr xmlns:a="http://schemas.openxmlformats.org/drawingml/2006/main"/>
-          <a:lstStyle xmlns:a="http://schemas.openxmlformats.org/drawingml/2006/main"/>
-          <a:p xmlns:a="http://schemas.openxmlformats.org/drawingml/2006/main">
-            <a:pPr algn="l">
-              <a:defRPr sz="1275" b="1">
-                <a:solidFill>
-                  <a:srgbClr val="E5533D"/>
-                </a:solidFill>
-              </a:defRPr>
-            </a:pPr>
-            <a:r>
-              <a:rPr sz="1275" b="1">
-                <a:solidFill>
-                  <a:srgbClr val="E5533D"/>
-                </a:solidFill>
-              </a:rPr>
-              <a:t>Repository URL was not supplied with the project files.</a:t>
+                <a16:creationId xmlns:a16="http://schemas.microsoft.com/office/drawing/2014/main" id="{DAC8E96E-20BE-46BD-AB24-38E2B84F7968}"/>
+              </a:ext>
+            </a:extLst>
+          </p:cNvPr>
+          <p:cNvSpPr>
+            <a:spLocks xmlns:a="http://schemas.openxmlformats.org/drawingml/2006/main" noGrp="1"/>
+          </p:cNvSpPr>
+          <p:nvPr/>
+        </p:nvSpPr>
+        <p:spPr>
+          <a:xfrm xmlns:a="http://schemas.openxmlformats.org/drawingml/2006/main">
+            <a:off x="6524625" y="3762375"/>
+            <a:ext cx="4476750" cy="666750"/>
+          </a:xfrm>
+          <a:prstGeom xmlns:a="http://schemas.openxmlformats.org/drawingml/2006/main" prst="rect">
+            <a:avLst/>
+          </a:prstGeom>
+          <a:noFill xmlns:a="http://schemas.openxmlformats.org/drawingml/2006/main"/>
+          <a:ln xmlns:a="http://schemas.openxmlformats.org/drawingml/2006/main" w="0">
+            <a:noFill/>
+            <a:prstDash val="solid"/>
+          </a:ln>
+        </p:spPr>
+        <p:txBody>
+          <a:bodyPr xmlns:a="http://schemas.openxmlformats.org/drawingml/2006/main"/>
+          <a:lstStyle xmlns:a="http://schemas.openxmlformats.org/drawingml/2006/main"/>
+          <a:p xmlns:a="http://schemas.openxmlformats.org/drawingml/2006/main">
+            <a:pPr algn="l">
+              <a:defRPr sz="1125" b="1">
+                <a:solidFill>
+                  <a:srgbClr val="3D8DFF"/>
+                </a:solidFill>
+              </a:defRPr>
+            </a:pPr>
+            <a:r>
+              <a:rPr sz="1125" b="1">
+                <a:solidFill>
+                  <a:srgbClr val="3D8DFF"/>
+                </a:solidFill>
+              </a:rPr>
+              <a:t>https://github.com/TristinWen/spacex-falcon9-landing-prediction</a:t>
             </a:r>
           </a:p>
         </p:txBody>
@@ -4990,7 +4995,7 @@
     </p:spTree>
     <p:extLst>
       <p:ext uri="{BB962C8B-B14F-4D97-AF65-F5344CB8AC3E}">
-        <p14:creationId xmlns:p14="http://schemas.microsoft.com/office/powerpoint/2010/main" val="1293766290"/>
+        <p14:creationId xmlns:p14="http://schemas.microsoft.com/office/powerpoint/2010/main" val="438062516"/>
       </p:ext>
     </p:extLst>
   </p:cSld>
@@ -5021,7 +5026,7 @@
           <p:cNvPr id="15" name="">
             <a:extLst xmlns:a="http://schemas.openxmlformats.org/drawingml/2006/main">
               <a:ext uri="{FF2B5EF4-FFF2-40B4-BE49-F238E27FC236}">
-                <a16:creationId xmlns:a16="http://schemas.microsoft.com/office/drawing/2014/main" id="{B35ACF11-3FFF-415B-8595-148C6D199592}"/>
+                <a16:creationId xmlns:a16="http://schemas.microsoft.com/office/drawing/2014/main" id="{3DBE1742-1DDD-4CCC-8223-ECF157659818}"/>
               </a:ext>
             </a:extLst>
           </p:cNvPr>
@@ -5071,7 +5076,7 @@
           <p:cNvPr id="2" name="">
             <a:extLst xmlns:a="http://schemas.openxmlformats.org/drawingml/2006/main">
               <a:ext uri="{FF2B5EF4-FFF2-40B4-BE49-F238E27FC236}">
-                <a16:creationId xmlns:a16="http://schemas.microsoft.com/office/drawing/2014/main" id="{65EACCBB-8935-4174-A62E-46882FF2D9A8}"/>
+                <a16:creationId xmlns:a16="http://schemas.microsoft.com/office/drawing/2014/main" id="{6D59D412-D9EC-441D-A0BA-99F9FE1DE4F4}"/>
               </a:ext>
             </a:extLst>
           </p:cNvPr>
@@ -5121,7 +5126,7 @@
           <p:cNvPr id="3" name="">
             <a:extLst xmlns:a="http://schemas.openxmlformats.org/drawingml/2006/main">
               <a:ext uri="{FF2B5EF4-FFF2-40B4-BE49-F238E27FC236}">
-                <a16:creationId xmlns:a16="http://schemas.microsoft.com/office/drawing/2014/main" id="{5B3D48F0-0ADE-43B6-87FB-04A4E48EB258}"/>
+                <a16:creationId xmlns:a16="http://schemas.microsoft.com/office/drawing/2014/main" id="{CEC7CEF8-A1A3-41EB-95B2-271D522608AD}"/>
               </a:ext>
             </a:extLst>
           </p:cNvPr>
@@ -5152,7 +5157,7 @@
           <p:cNvPr id="4" name="">
             <a:extLst xmlns:a="http://schemas.openxmlformats.org/drawingml/2006/main">
               <a:ext uri="{FF2B5EF4-FFF2-40B4-BE49-F238E27FC236}">
-                <a16:creationId xmlns:a16="http://schemas.microsoft.com/office/drawing/2014/main" id="{404256F3-30F9-45E5-9689-72245C9DE451}"/>
+                <a16:creationId xmlns:a16="http://schemas.microsoft.com/office/drawing/2014/main" id="{0923CF1E-57C5-4383-ACE7-34F5579C53FF}"/>
               </a:ext>
             </a:extLst>
           </p:cNvPr>
@@ -5202,7 +5207,7 @@
           <p:cNvPr id="5" name="">
             <a:extLst xmlns:a="http://schemas.openxmlformats.org/drawingml/2006/main">
               <a:ext uri="{FF2B5EF4-FFF2-40B4-BE49-F238E27FC236}">
-                <a16:creationId xmlns:a16="http://schemas.microsoft.com/office/drawing/2014/main" id="{BC4C66BD-4F0E-484D-99BE-4924F06A64E0}"/>
+                <a16:creationId xmlns:a16="http://schemas.microsoft.com/office/drawing/2014/main" id="{3AD76A42-BA71-4754-9010-96EED8348916}"/>
               </a:ext>
             </a:extLst>
           </p:cNvPr>
@@ -5252,7 +5257,7 @@
           <p:cNvPr id="6" name="">
             <a:extLst xmlns:a="http://schemas.openxmlformats.org/drawingml/2006/main">
               <a:ext uri="{FF2B5EF4-FFF2-40B4-BE49-F238E27FC236}">
-                <a16:creationId xmlns:a16="http://schemas.microsoft.com/office/drawing/2014/main" id="{339F7717-DB4C-4B0C-AA70-734C15EEB97F}"/>
+                <a16:creationId xmlns:a16="http://schemas.microsoft.com/office/drawing/2014/main" id="{B5BCF40D-89E2-4DA0-A083-90C3E26FA983}"/>
               </a:ext>
             </a:extLst>
           </p:cNvPr>
@@ -5302,7 +5307,7 @@
           <p:cNvPr id="7" name="">
             <a:extLst xmlns:a="http://schemas.openxmlformats.org/drawingml/2006/main">
               <a:ext uri="{FF2B5EF4-FFF2-40B4-BE49-F238E27FC236}">
-                <a16:creationId xmlns:a16="http://schemas.microsoft.com/office/drawing/2014/main" id="{C34A38F1-F2B1-47D8-8CEA-48C8E59CD451}"/>
+                <a16:creationId xmlns:a16="http://schemas.microsoft.com/office/drawing/2014/main" id="{68B814ED-F763-45CE-BD81-E8A4AF53411A}"/>
               </a:ext>
             </a:extLst>
           </p:cNvPr>
@@ -5352,7 +5357,7 @@
           <p:cNvPr id="8" name="">
             <a:extLst xmlns:a="http://schemas.openxmlformats.org/drawingml/2006/main">
               <a:ext uri="{FF2B5EF4-FFF2-40B4-BE49-F238E27FC236}">
-                <a16:creationId xmlns:a16="http://schemas.microsoft.com/office/drawing/2014/main" id="{93308977-448E-4103-94A1-530AE6987027}"/>
+                <a16:creationId xmlns:a16="http://schemas.microsoft.com/office/drawing/2014/main" id="{68914495-4CDC-45FB-90D3-2FD2F957BE93}"/>
               </a:ext>
             </a:extLst>
           </p:cNvPr>
@@ -5402,7 +5407,7 @@
           <p:cNvPr id="9" name="">
             <a:extLst xmlns:a="http://schemas.openxmlformats.org/drawingml/2006/main">
               <a:ext uri="{FF2B5EF4-FFF2-40B4-BE49-F238E27FC236}">
-                <a16:creationId xmlns:a16="http://schemas.microsoft.com/office/drawing/2014/main" id="{15772E86-CC67-46AC-AD04-EAB3325B05B6}"/>
+                <a16:creationId xmlns:a16="http://schemas.microsoft.com/office/drawing/2014/main" id="{0F80B32B-50E2-4D9C-81E1-FBD8D7011C93}"/>
               </a:ext>
             </a:extLst>
           </p:cNvPr>
@@ -5452,7 +5457,7 @@
           <p:cNvPr id="10" name="">
             <a:extLst xmlns:a="http://schemas.openxmlformats.org/drawingml/2006/main">
               <a:ext uri="{FF2B5EF4-FFF2-40B4-BE49-F238E27FC236}">
-                <a16:creationId xmlns:a16="http://schemas.microsoft.com/office/drawing/2014/main" id="{56B349EB-6326-4A81-A329-B9B2F95617AD}"/>
+                <a16:creationId xmlns:a16="http://schemas.microsoft.com/office/drawing/2014/main" id="{6961E000-BC6D-4012-882E-4C6232ACE159}"/>
               </a:ext>
             </a:extLst>
           </p:cNvPr>
@@ -5502,7 +5507,7 @@
           <p:cNvPr id="11" name="">
             <a:extLst xmlns:a="http://schemas.openxmlformats.org/drawingml/2006/main">
               <a:ext uri="{FF2B5EF4-FFF2-40B4-BE49-F238E27FC236}">
-                <a16:creationId xmlns:a16="http://schemas.microsoft.com/office/drawing/2014/main" id="{32E453DA-B9E7-4133-9926-FB4DC3DC7920}"/>
+                <a16:creationId xmlns:a16="http://schemas.microsoft.com/office/drawing/2014/main" id="{A9E94242-5341-455A-A261-F4B7BE7373BE}"/>
               </a:ext>
             </a:extLst>
           </p:cNvPr>
@@ -5552,7 +5557,7 @@
           <p:cNvPr id="12" name="">
             <a:extLst xmlns:a="http://schemas.openxmlformats.org/drawingml/2006/main">
               <a:ext uri="{FF2B5EF4-FFF2-40B4-BE49-F238E27FC236}">
-                <a16:creationId xmlns:a16="http://schemas.microsoft.com/office/drawing/2014/main" id="{A22D9F37-00C0-4261-AC7E-8179B9F102DF}"/>
+                <a16:creationId xmlns:a16="http://schemas.microsoft.com/office/drawing/2014/main" id="{982ED4FF-6528-4BDF-8197-CB9F793A9C51}"/>
               </a:ext>
             </a:extLst>
           </p:cNvPr>
@@ -5602,7 +5607,7 @@
           <p:cNvPr id="13" name="">
             <a:extLst xmlns:a="http://schemas.openxmlformats.org/drawingml/2006/main">
               <a:ext uri="{FF2B5EF4-FFF2-40B4-BE49-F238E27FC236}">
-                <a16:creationId xmlns:a16="http://schemas.microsoft.com/office/drawing/2014/main" id="{6B989CA7-81FA-4AFF-8383-23D47EFAD4F3}"/>
+                <a16:creationId xmlns:a16="http://schemas.microsoft.com/office/drawing/2014/main" id="{813E44DE-6E53-49BB-AACD-EF2B20259932}"/>
               </a:ext>
             </a:extLst>
           </p:cNvPr>
@@ -5652,7 +5657,7 @@
           <p:cNvPr id="14" name="">
             <a:extLst xmlns:a="http://schemas.openxmlformats.org/drawingml/2006/main">
               <a:ext uri="{FF2B5EF4-FFF2-40B4-BE49-F238E27FC236}">
-                <a16:creationId xmlns:a16="http://schemas.microsoft.com/office/drawing/2014/main" id="{2D0FDF24-2ADB-4E14-A257-88C9FDAFAE8B}"/>
+                <a16:creationId xmlns:a16="http://schemas.microsoft.com/office/drawing/2014/main" id="{2003E974-D9C5-49C8-A907-78CCC5AFAA69}"/>
               </a:ext>
             </a:extLst>
           </p:cNvPr>
@@ -5700,7 +5705,7 @@
     </p:spTree>
     <p:extLst>
       <p:ext uri="{BB962C8B-B14F-4D97-AF65-F5344CB8AC3E}">
-        <p14:creationId xmlns:p14="http://schemas.microsoft.com/office/powerpoint/2010/main" val="294539866"/>
+        <p14:creationId xmlns:p14="http://schemas.microsoft.com/office/powerpoint/2010/main" val="1564842333"/>
       </p:ext>
     </p:extLst>
   </p:cSld>
@@ -5731,7 +5736,7 @@
           <p:cNvPr id="32" name="">
             <a:extLst xmlns:a="http://schemas.openxmlformats.org/drawingml/2006/main">
               <a:ext uri="{FF2B5EF4-FFF2-40B4-BE49-F238E27FC236}">
-                <a16:creationId xmlns:a16="http://schemas.microsoft.com/office/drawing/2014/main" id="{7AC22A33-50DE-4F69-A7B6-6A1FA5664155}"/>
+                <a16:creationId xmlns:a16="http://schemas.microsoft.com/office/drawing/2014/main" id="{B378BF95-CAA8-4042-AE90-9173827E7C11}"/>
               </a:ext>
             </a:extLst>
           </p:cNvPr>
@@ -5781,7 +5786,7 @@
           <p:cNvPr id="2" name="">
             <a:extLst xmlns:a="http://schemas.openxmlformats.org/drawingml/2006/main">
               <a:ext uri="{FF2B5EF4-FFF2-40B4-BE49-F238E27FC236}">
-                <a16:creationId xmlns:a16="http://schemas.microsoft.com/office/drawing/2014/main" id="{57D0ADC9-7016-4BEC-9CFF-3BB3D0123CA0}"/>
+                <a16:creationId xmlns:a16="http://schemas.microsoft.com/office/drawing/2014/main" id="{A8559A59-DC99-4DB0-A4D5-A824AF053EC8}"/>
               </a:ext>
             </a:extLst>
           </p:cNvPr>
@@ -5831,7 +5836,7 @@
           <p:cNvPr id="3" name="">
             <a:extLst xmlns:a="http://schemas.openxmlformats.org/drawingml/2006/main">
               <a:ext uri="{FF2B5EF4-FFF2-40B4-BE49-F238E27FC236}">
-                <a16:creationId xmlns:a16="http://schemas.microsoft.com/office/drawing/2014/main" id="{B81640A4-0575-4AD1-955B-19D78FC5041A}"/>
+                <a16:creationId xmlns:a16="http://schemas.microsoft.com/office/drawing/2014/main" id="{855BEC53-2D9E-4FB7-AF20-88EB3D6880D8}"/>
               </a:ext>
             </a:extLst>
           </p:cNvPr>
@@ -5862,7 +5867,7 @@
           <p:cNvPr id="4" name="">
             <a:extLst xmlns:a="http://schemas.openxmlformats.org/drawingml/2006/main">
               <a:ext uri="{FF2B5EF4-FFF2-40B4-BE49-F238E27FC236}">
-                <a16:creationId xmlns:a16="http://schemas.microsoft.com/office/drawing/2014/main" id="{7E2E1984-B8B9-41F1-A4C8-927454B51CBA}"/>
+                <a16:creationId xmlns:a16="http://schemas.microsoft.com/office/drawing/2014/main" id="{3F78BF4B-D855-477A-8AF1-2344D2455386}"/>
               </a:ext>
             </a:extLst>
           </p:cNvPr>
@@ -5893,7 +5898,7 @@
           <p:cNvPr id="5" name="">
             <a:extLst xmlns:a="http://schemas.openxmlformats.org/drawingml/2006/main">
               <a:ext uri="{FF2B5EF4-FFF2-40B4-BE49-F238E27FC236}">
-                <a16:creationId xmlns:a16="http://schemas.microsoft.com/office/drawing/2014/main" id="{55EE0FD5-2FA8-4A88-9318-5A69D2DC3E73}"/>
+                <a16:creationId xmlns:a16="http://schemas.microsoft.com/office/drawing/2014/main" id="{B12C60C5-8D9D-4C7D-B9B5-1FA99C8679E1}"/>
               </a:ext>
             </a:extLst>
           </p:cNvPr>
@@ -5943,7 +5948,7 @@
           <p:cNvPr id="6" name="">
             <a:extLst xmlns:a="http://schemas.openxmlformats.org/drawingml/2006/main">
               <a:ext uri="{FF2B5EF4-FFF2-40B4-BE49-F238E27FC236}">
-                <a16:creationId xmlns:a16="http://schemas.microsoft.com/office/drawing/2014/main" id="{0BC808A2-D767-486F-A32B-9FA0D3AEA237}"/>
+                <a16:creationId xmlns:a16="http://schemas.microsoft.com/office/drawing/2014/main" id="{73F045BC-B6D2-4DA0-A046-63D7C79B5284}"/>
               </a:ext>
             </a:extLst>
           </p:cNvPr>
@@ -5993,7 +5998,7 @@
           <p:cNvPr id="7" name="">
             <a:extLst xmlns:a="http://schemas.openxmlformats.org/drawingml/2006/main">
               <a:ext uri="{FF2B5EF4-FFF2-40B4-BE49-F238E27FC236}">
-                <a16:creationId xmlns:a16="http://schemas.microsoft.com/office/drawing/2014/main" id="{E64E86CD-9EA8-409E-B91F-FC14056C7E02}"/>
+                <a16:creationId xmlns:a16="http://schemas.microsoft.com/office/drawing/2014/main" id="{5B7AFE18-C6D0-4D30-8C0F-0CD5AF40E8A3}"/>
               </a:ext>
             </a:extLst>
           </p:cNvPr>
@@ -6043,7 +6048,7 @@
           <p:cNvPr id="8" name="">
             <a:extLst xmlns:a="http://schemas.openxmlformats.org/drawingml/2006/main">
               <a:ext uri="{FF2B5EF4-FFF2-40B4-BE49-F238E27FC236}">
-                <a16:creationId xmlns:a16="http://schemas.microsoft.com/office/drawing/2014/main" id="{F6F2B41F-76A6-4C88-9A53-2F5FE3652278}"/>
+                <a16:creationId xmlns:a16="http://schemas.microsoft.com/office/drawing/2014/main" id="{4B9D7F0C-2B11-4CAA-9148-E91CD7A91933}"/>
               </a:ext>
             </a:extLst>
           </p:cNvPr>
@@ -6074,7 +6079,7 @@
           <p:cNvPr id="9" name="">
             <a:extLst xmlns:a="http://schemas.openxmlformats.org/drawingml/2006/main">
               <a:ext uri="{FF2B5EF4-FFF2-40B4-BE49-F238E27FC236}">
-                <a16:creationId xmlns:a16="http://schemas.microsoft.com/office/drawing/2014/main" id="{14612AE2-0AB3-442D-A8EF-254029BC0E2D}"/>
+                <a16:creationId xmlns:a16="http://schemas.microsoft.com/office/drawing/2014/main" id="{44074D73-9BCD-4C2A-B000-2AD301DB808F}"/>
               </a:ext>
             </a:extLst>
           </p:cNvPr>
@@ -6124,7 +6129,7 @@
           <p:cNvPr id="10" name="">
             <a:extLst xmlns:a="http://schemas.openxmlformats.org/drawingml/2006/main">
               <a:ext uri="{FF2B5EF4-FFF2-40B4-BE49-F238E27FC236}">
-                <a16:creationId xmlns:a16="http://schemas.microsoft.com/office/drawing/2014/main" id="{97433EBB-A6DC-4988-B9B3-8F09F859AFD7}"/>
+                <a16:creationId xmlns:a16="http://schemas.microsoft.com/office/drawing/2014/main" id="{E9672B8F-DB7F-4F64-8308-56179AD17D72}"/>
               </a:ext>
             </a:extLst>
           </p:cNvPr>
@@ -6174,7 +6179,7 @@
           <p:cNvPr id="11" name="">
             <a:extLst xmlns:a="http://schemas.openxmlformats.org/drawingml/2006/main">
               <a:ext uri="{FF2B5EF4-FFF2-40B4-BE49-F238E27FC236}">
-                <a16:creationId xmlns:a16="http://schemas.microsoft.com/office/drawing/2014/main" id="{CE32DF46-DB71-40C9-B566-DA516DB4B8C4}"/>
+                <a16:creationId xmlns:a16="http://schemas.microsoft.com/office/drawing/2014/main" id="{1598D88F-101B-4A30-B852-0069576C78A7}"/>
               </a:ext>
             </a:extLst>
           </p:cNvPr>
@@ -6224,7 +6229,7 @@
           <p:cNvPr id="12" name="">
             <a:extLst xmlns:a="http://schemas.openxmlformats.org/drawingml/2006/main">
               <a:ext uri="{FF2B5EF4-FFF2-40B4-BE49-F238E27FC236}">
-                <a16:creationId xmlns:a16="http://schemas.microsoft.com/office/drawing/2014/main" id="{2A4E0828-E7EC-44C7-A00B-E9724A383B9A}"/>
+                <a16:creationId xmlns:a16="http://schemas.microsoft.com/office/drawing/2014/main" id="{F88B1FE7-89B9-4E1A-9A66-0645D42F384A}"/>
               </a:ext>
             </a:extLst>
           </p:cNvPr>
@@ -6255,7 +6260,7 @@
           <p:cNvPr id="13" name="">
             <a:extLst xmlns:a="http://schemas.openxmlformats.org/drawingml/2006/main">
               <a:ext uri="{FF2B5EF4-FFF2-40B4-BE49-F238E27FC236}">
-                <a16:creationId xmlns:a16="http://schemas.microsoft.com/office/drawing/2014/main" id="{DADBEDC3-B703-4254-A548-61270C4D530A}"/>
+                <a16:creationId xmlns:a16="http://schemas.microsoft.com/office/drawing/2014/main" id="{C298AF4E-FE89-4A13-9E24-9669063B957A}"/>
               </a:ext>
             </a:extLst>
           </p:cNvPr>
@@ -6305,7 +6310,7 @@
           <p:cNvPr id="14" name="">
             <a:extLst xmlns:a="http://schemas.openxmlformats.org/drawingml/2006/main">
               <a:ext uri="{FF2B5EF4-FFF2-40B4-BE49-F238E27FC236}">
-                <a16:creationId xmlns:a16="http://schemas.microsoft.com/office/drawing/2014/main" id="{AAD614AD-19E6-4518-8049-C16C53B688DC}"/>
+                <a16:creationId xmlns:a16="http://schemas.microsoft.com/office/drawing/2014/main" id="{96F907F1-9E7F-4C28-83CD-33ACDF9F4A14}"/>
               </a:ext>
             </a:extLst>
           </p:cNvPr>
@@ -6355,7 +6360,7 @@
           <p:cNvPr id="15" name="">
             <a:extLst xmlns:a="http://schemas.openxmlformats.org/drawingml/2006/main">
               <a:ext uri="{FF2B5EF4-FFF2-40B4-BE49-F238E27FC236}">
-                <a16:creationId xmlns:a16="http://schemas.microsoft.com/office/drawing/2014/main" id="{75C5F49A-CF09-40C6-A80B-CD1A143A7274}"/>
+                <a16:creationId xmlns:a16="http://schemas.microsoft.com/office/drawing/2014/main" id="{09B36E16-2244-466A-A50A-16B6CC6A6DB9}"/>
               </a:ext>
             </a:extLst>
           </p:cNvPr>
@@ -6405,7 +6410,7 @@
           <p:cNvPr id="16" name="">
             <a:extLst xmlns:a="http://schemas.openxmlformats.org/drawingml/2006/main">
               <a:ext uri="{FF2B5EF4-FFF2-40B4-BE49-F238E27FC236}">
-                <a16:creationId xmlns:a16="http://schemas.microsoft.com/office/drawing/2014/main" id="{80CC70A4-1BF9-4672-ADAF-D1B20DA7EF92}"/>
+                <a16:creationId xmlns:a16="http://schemas.microsoft.com/office/drawing/2014/main" id="{3CD6D06E-63C1-4885-9729-D74EF85F7B8E}"/>
               </a:ext>
             </a:extLst>
           </p:cNvPr>
@@ -6436,7 +6441,7 @@
           <p:cNvPr id="17" name="">
             <a:extLst xmlns:a="http://schemas.openxmlformats.org/drawingml/2006/main">
               <a:ext uri="{FF2B5EF4-FFF2-40B4-BE49-F238E27FC236}">
-                <a16:creationId xmlns:a16="http://schemas.microsoft.com/office/drawing/2014/main" id="{24D95751-27ED-424E-8429-02BD12D4324E}"/>
+                <a16:creationId xmlns:a16="http://schemas.microsoft.com/office/drawing/2014/main" id="{A13FE216-79AC-4211-8575-F07910166B9E}"/>
               </a:ext>
             </a:extLst>
           </p:cNvPr>
@@ -6486,7 +6491,7 @@
           <p:cNvPr id="18" name="">
             <a:extLst xmlns:a="http://schemas.openxmlformats.org/drawingml/2006/main">
               <a:ext uri="{FF2B5EF4-FFF2-40B4-BE49-F238E27FC236}">
-                <a16:creationId xmlns:a16="http://schemas.microsoft.com/office/drawing/2014/main" id="{5B31449F-8056-4EE5-ADAB-6293F1101B34}"/>
+                <a16:creationId xmlns:a16="http://schemas.microsoft.com/office/drawing/2014/main" id="{49F6E606-E69C-4CB5-ABB1-58EB4D3A36C9}"/>
               </a:ext>
             </a:extLst>
           </p:cNvPr>
@@ -6536,7 +6541,7 @@
           <p:cNvPr id="19" name="">
             <a:extLst xmlns:a="http://schemas.openxmlformats.org/drawingml/2006/main">
               <a:ext uri="{FF2B5EF4-FFF2-40B4-BE49-F238E27FC236}">
-                <a16:creationId xmlns:a16="http://schemas.microsoft.com/office/drawing/2014/main" id="{C96FB41A-93AB-44E1-AFB1-9AADD980342F}"/>
+                <a16:creationId xmlns:a16="http://schemas.microsoft.com/office/drawing/2014/main" id="{B457E6E9-5E19-4C42-95F9-908B249BBCF7}"/>
               </a:ext>
             </a:extLst>
           </p:cNvPr>
@@ -6586,7 +6591,7 @@
           <p:cNvPr id="20" name="">
             <a:extLst xmlns:a="http://schemas.openxmlformats.org/drawingml/2006/main">
               <a:ext uri="{FF2B5EF4-FFF2-40B4-BE49-F238E27FC236}">
-                <a16:creationId xmlns:a16="http://schemas.microsoft.com/office/drawing/2014/main" id="{A3476743-BFBE-4FDC-AAC8-D45BAC587DA3}"/>
+                <a16:creationId xmlns:a16="http://schemas.microsoft.com/office/drawing/2014/main" id="{687F64E3-4077-4E89-A580-CDB06944F6F3}"/>
               </a:ext>
             </a:extLst>
           </p:cNvPr>
@@ -6617,7 +6622,7 @@
           <p:cNvPr id="21" name="">
             <a:extLst xmlns:a="http://schemas.openxmlformats.org/drawingml/2006/main">
               <a:ext uri="{FF2B5EF4-FFF2-40B4-BE49-F238E27FC236}">
-                <a16:creationId xmlns:a16="http://schemas.microsoft.com/office/drawing/2014/main" id="{1F41F688-7A72-45BB-AF82-7536E32A7690}"/>
+                <a16:creationId xmlns:a16="http://schemas.microsoft.com/office/drawing/2014/main" id="{87C7817C-9566-436B-A728-3A2E7EA1B5C4}"/>
               </a:ext>
             </a:extLst>
           </p:cNvPr>
@@ -6667,7 +6672,7 @@
           <p:cNvPr id="22" name="">
             <a:extLst xmlns:a="http://schemas.openxmlformats.org/drawingml/2006/main">
               <a:ext uri="{FF2B5EF4-FFF2-40B4-BE49-F238E27FC236}">
-                <a16:creationId xmlns:a16="http://schemas.microsoft.com/office/drawing/2014/main" id="{F856B733-9E6C-4788-8654-A649190B5B20}"/>
+                <a16:creationId xmlns:a16="http://schemas.microsoft.com/office/drawing/2014/main" id="{4E3D3548-57E8-43C4-AE2B-A1AF6556AA3F}"/>
               </a:ext>
             </a:extLst>
           </p:cNvPr>
@@ -6717,7 +6722,7 @@
           <p:cNvPr id="23" name="">
             <a:extLst xmlns:a="http://schemas.openxmlformats.org/drawingml/2006/main">
               <a:ext uri="{FF2B5EF4-FFF2-40B4-BE49-F238E27FC236}">
-                <a16:creationId xmlns:a16="http://schemas.microsoft.com/office/drawing/2014/main" id="{8F22CC93-C0EC-410E-8D6F-3D280E9E6361}"/>
+                <a16:creationId xmlns:a16="http://schemas.microsoft.com/office/drawing/2014/main" id="{6442FA88-A045-4FEE-A377-F558268451B5}"/>
               </a:ext>
             </a:extLst>
           </p:cNvPr>
@@ -6767,7 +6772,7 @@
           <p:cNvPr id="24" name="">
             <a:extLst xmlns:a="http://schemas.openxmlformats.org/drawingml/2006/main">
               <a:ext uri="{FF2B5EF4-FFF2-40B4-BE49-F238E27FC236}">
-                <a16:creationId xmlns:a16="http://schemas.microsoft.com/office/drawing/2014/main" id="{3FC94991-FC5F-4E2D-BAD4-62C4F51A995F}"/>
+                <a16:creationId xmlns:a16="http://schemas.microsoft.com/office/drawing/2014/main" id="{1C8B86E8-60E9-44B9-97AE-2417360E96A3}"/>
               </a:ext>
             </a:extLst>
           </p:cNvPr>
@@ -6798,7 +6803,7 @@
           <p:cNvPr id="25" name="">
             <a:extLst xmlns:a="http://schemas.openxmlformats.org/drawingml/2006/main">
               <a:ext uri="{FF2B5EF4-FFF2-40B4-BE49-F238E27FC236}">
-                <a16:creationId xmlns:a16="http://schemas.microsoft.com/office/drawing/2014/main" id="{40573DF7-95C2-40A1-8FD7-221DF607712A}"/>
+                <a16:creationId xmlns:a16="http://schemas.microsoft.com/office/drawing/2014/main" id="{99307ADA-2A9E-4B31-AA7F-2924D2DC0A50}"/>
               </a:ext>
             </a:extLst>
           </p:cNvPr>
@@ -6848,7 +6853,7 @@
           <p:cNvPr id="26" name="">
             <a:extLst xmlns:a="http://schemas.openxmlformats.org/drawingml/2006/main">
               <a:ext uri="{FF2B5EF4-FFF2-40B4-BE49-F238E27FC236}">
-                <a16:creationId xmlns:a16="http://schemas.microsoft.com/office/drawing/2014/main" id="{92A8FDF3-3A16-4B40-9A5B-BDD5FDF03D64}"/>
+                <a16:creationId xmlns:a16="http://schemas.microsoft.com/office/drawing/2014/main" id="{163BA7E7-2ED0-4523-A911-975D58EE8B1D}"/>
               </a:ext>
             </a:extLst>
           </p:cNvPr>
@@ -6898,7 +6903,7 @@
           <p:cNvPr id="27" name="">
             <a:extLst xmlns:a="http://schemas.openxmlformats.org/drawingml/2006/main">
               <a:ext uri="{FF2B5EF4-FFF2-40B4-BE49-F238E27FC236}">
-                <a16:creationId xmlns:a16="http://schemas.microsoft.com/office/drawing/2014/main" id="{6183794A-E4EF-48D5-88D3-B03915901FD3}"/>
+                <a16:creationId xmlns:a16="http://schemas.microsoft.com/office/drawing/2014/main" id="{253F5DF6-DFE5-4EC2-8239-2FF9343DB7CF}"/>
               </a:ext>
             </a:extLst>
           </p:cNvPr>
@@ -6948,7 +6953,7 @@
           <p:cNvPr id="28" name="">
             <a:extLst xmlns:a="http://schemas.openxmlformats.org/drawingml/2006/main">
               <a:ext uri="{FF2B5EF4-FFF2-40B4-BE49-F238E27FC236}">
-                <a16:creationId xmlns:a16="http://schemas.microsoft.com/office/drawing/2014/main" id="{CBFA0CB3-81AA-414E-B03B-9CECE2982D7E}"/>
+                <a16:creationId xmlns:a16="http://schemas.microsoft.com/office/drawing/2014/main" id="{05FB4B80-3BCF-45D1-88D5-76617D190ABC}"/>
               </a:ext>
             </a:extLst>
           </p:cNvPr>
@@ -6979,7 +6984,7 @@
           <p:cNvPr id="29" name="">
             <a:extLst xmlns:a="http://schemas.openxmlformats.org/drawingml/2006/main">
               <a:ext uri="{FF2B5EF4-FFF2-40B4-BE49-F238E27FC236}">
-                <a16:creationId xmlns:a16="http://schemas.microsoft.com/office/drawing/2014/main" id="{78CDE364-B94F-4F98-AC2E-9607C53BA59A}"/>
+                <a16:creationId xmlns:a16="http://schemas.microsoft.com/office/drawing/2014/main" id="{F0FB0198-FBEB-407D-AA1C-CCBDB58BB375}"/>
               </a:ext>
             </a:extLst>
           </p:cNvPr>
@@ -7029,7 +7034,7 @@
           <p:cNvPr id="30" name="">
             <a:extLst xmlns:a="http://schemas.openxmlformats.org/drawingml/2006/main">
               <a:ext uri="{FF2B5EF4-FFF2-40B4-BE49-F238E27FC236}">
-                <a16:creationId xmlns:a16="http://schemas.microsoft.com/office/drawing/2014/main" id="{548CF209-3F01-480E-85E2-B63EEA5BEB28}"/>
+                <a16:creationId xmlns:a16="http://schemas.microsoft.com/office/drawing/2014/main" id="{131952E2-ECD1-4946-A2D1-C3B8A7CBF3F7}"/>
               </a:ext>
             </a:extLst>
           </p:cNvPr>
@@ -7079,7 +7084,7 @@
           <p:cNvPr id="31" name="">
             <a:extLst xmlns:a="http://schemas.openxmlformats.org/drawingml/2006/main">
               <a:ext uri="{FF2B5EF4-FFF2-40B4-BE49-F238E27FC236}">
-                <a16:creationId xmlns:a16="http://schemas.microsoft.com/office/drawing/2014/main" id="{6CA28D9B-88EA-4FB3-82FF-F66FAA972483}"/>
+                <a16:creationId xmlns:a16="http://schemas.microsoft.com/office/drawing/2014/main" id="{D6B0545D-7BAE-40B2-9ABA-DC841B40296C}"/>
               </a:ext>
             </a:extLst>
           </p:cNvPr>
@@ -7127,7 +7132,7 @@
     </p:spTree>
     <p:extLst>
       <p:ext uri="{BB962C8B-B14F-4D97-AF65-F5344CB8AC3E}">
-        <p14:creationId xmlns:p14="http://schemas.microsoft.com/office/powerpoint/2010/main" val="1271444386"/>
+        <p14:creationId xmlns:p14="http://schemas.microsoft.com/office/powerpoint/2010/main" val="414303514"/>
       </p:ext>
     </p:extLst>
   </p:cSld>
@@ -7158,7 +7163,7 @@
           <p:cNvPr id="11" name="">
             <a:extLst xmlns:a="http://schemas.openxmlformats.org/drawingml/2006/main">
               <a:ext uri="{FF2B5EF4-FFF2-40B4-BE49-F238E27FC236}">
-                <a16:creationId xmlns:a16="http://schemas.microsoft.com/office/drawing/2014/main" id="{7FEFE55A-E139-4988-8F4C-A7B8B0129C6D}"/>
+                <a16:creationId xmlns:a16="http://schemas.microsoft.com/office/drawing/2014/main" id="{538D8F10-8EDE-43C3-81CD-C839BFDACCE8}"/>
               </a:ext>
             </a:extLst>
           </p:cNvPr>
@@ -7208,7 +7213,7 @@
           <p:cNvPr id="2" name="">
             <a:extLst xmlns:a="http://schemas.openxmlformats.org/drawingml/2006/main">
               <a:ext uri="{FF2B5EF4-FFF2-40B4-BE49-F238E27FC236}">
-                <a16:creationId xmlns:a16="http://schemas.microsoft.com/office/drawing/2014/main" id="{E6AB0C8C-8A04-42F7-818D-01148571035D}"/>
+                <a16:creationId xmlns:a16="http://schemas.microsoft.com/office/drawing/2014/main" id="{6237EF97-81BC-4290-9B21-188C13CC4BC0}"/>
               </a:ext>
             </a:extLst>
           </p:cNvPr>
@@ -7258,7 +7263,7 @@
           <p:cNvPr id="3" name="">
             <a:extLst xmlns:a="http://schemas.openxmlformats.org/drawingml/2006/main">
               <a:ext uri="{FF2B5EF4-FFF2-40B4-BE49-F238E27FC236}">
-                <a16:creationId xmlns:a16="http://schemas.microsoft.com/office/drawing/2014/main" id="{29441554-20D7-4F92-A30E-67FEBBFFF07E}"/>
+                <a16:creationId xmlns:a16="http://schemas.microsoft.com/office/drawing/2014/main" id="{E32E26E4-6B12-42EE-BC24-871D34195FD5}"/>
               </a:ext>
             </a:extLst>
           </p:cNvPr>
@@ -7289,7 +7294,7 @@
           <p:cNvPr id="4" name="">
             <a:extLst xmlns:a="http://schemas.openxmlformats.org/drawingml/2006/main">
               <a:ext uri="{FF2B5EF4-FFF2-40B4-BE49-F238E27FC236}">
-                <a16:creationId xmlns:a16="http://schemas.microsoft.com/office/drawing/2014/main" id="{570EA947-35D8-4A92-A035-7977B5820622}"/>
+                <a16:creationId xmlns:a16="http://schemas.microsoft.com/office/drawing/2014/main" id="{8D9CB346-166B-4060-A007-CEB9237D0A5B}"/>
               </a:ext>
             </a:extLst>
           </p:cNvPr>
@@ -7320,7 +7325,7 @@
           <p:cNvPr id="5" name="">
             <a:extLst xmlns:a="http://schemas.openxmlformats.org/drawingml/2006/main">
               <a:ext uri="{FF2B5EF4-FFF2-40B4-BE49-F238E27FC236}">
-                <a16:creationId xmlns:a16="http://schemas.microsoft.com/office/drawing/2014/main" id="{09A4958B-5DA1-4FE2-96EF-39BACF970F09}"/>
+                <a16:creationId xmlns:a16="http://schemas.microsoft.com/office/drawing/2014/main" id="{26F17A7C-8E46-447A-899E-7D10EEE32F46}"/>
               </a:ext>
             </a:extLst>
           </p:cNvPr>
@@ -7370,7 +7375,7 @@
           <p:cNvPr id="6" name="">
             <a:extLst xmlns:a="http://schemas.openxmlformats.org/drawingml/2006/main">
               <a:ext uri="{FF2B5EF4-FFF2-40B4-BE49-F238E27FC236}">
-                <a16:creationId xmlns:a16="http://schemas.microsoft.com/office/drawing/2014/main" id="{3788AAF2-30BB-4395-9579-88EFF96EEE6C}"/>
+                <a16:creationId xmlns:a16="http://schemas.microsoft.com/office/drawing/2014/main" id="{4028C026-65FF-4883-B622-93C2BC7CABF4}"/>
               </a:ext>
             </a:extLst>
           </p:cNvPr>
@@ -7454,7 +7459,7 @@
           <p:cNvPr id="7" name="">
             <a:extLst xmlns:a="http://schemas.openxmlformats.org/drawingml/2006/main">
               <a:ext uri="{FF2B5EF4-FFF2-40B4-BE49-F238E27FC236}">
-                <a16:creationId xmlns:a16="http://schemas.microsoft.com/office/drawing/2014/main" id="{76DB2F9E-E83A-4D19-BD31-4445450C005D}"/>
+                <a16:creationId xmlns:a16="http://schemas.microsoft.com/office/drawing/2014/main" id="{D5560FA1-7BD6-490B-B49E-250794BB9DDD}"/>
               </a:ext>
             </a:extLst>
           </p:cNvPr>
@@ -7485,7 +7490,7 @@
           <p:cNvPr id="8" name="">
             <a:extLst xmlns:a="http://schemas.openxmlformats.org/drawingml/2006/main">
               <a:ext uri="{FF2B5EF4-FFF2-40B4-BE49-F238E27FC236}">
-                <a16:creationId xmlns:a16="http://schemas.microsoft.com/office/drawing/2014/main" id="{E366B8C1-7826-4CA6-89A0-9F54DD0ACF8C}"/>
+                <a16:creationId xmlns:a16="http://schemas.microsoft.com/office/drawing/2014/main" id="{43029485-32EF-42F1-89BA-A509E1E69C40}"/>
               </a:ext>
             </a:extLst>
           </p:cNvPr>
@@ -7535,7 +7540,7 @@
           <p:cNvPr id="9" name="">
             <a:extLst xmlns:a="http://schemas.openxmlformats.org/drawingml/2006/main">
               <a:ext uri="{FF2B5EF4-FFF2-40B4-BE49-F238E27FC236}">
-                <a16:creationId xmlns:a16="http://schemas.microsoft.com/office/drawing/2014/main" id="{23AD4EE6-A94E-4588-8304-652DFE2FF2BA}"/>
+                <a16:creationId xmlns:a16="http://schemas.microsoft.com/office/drawing/2014/main" id="{AB879880-34B1-4C40-8339-A2917AB700CE}"/>
               </a:ext>
             </a:extLst>
           </p:cNvPr>
@@ -7619,7 +7624,7 @@
           <p:cNvPr id="10" name="">
             <a:extLst xmlns:a="http://schemas.openxmlformats.org/drawingml/2006/main">
               <a:ext uri="{FF2B5EF4-FFF2-40B4-BE49-F238E27FC236}">
-                <a16:creationId xmlns:a16="http://schemas.microsoft.com/office/drawing/2014/main" id="{70BFEB90-8162-44C3-9F5C-8BC9495165ED}"/>
+                <a16:creationId xmlns:a16="http://schemas.microsoft.com/office/drawing/2014/main" id="{6B133E00-C626-4D75-8CAD-AAB4F3D52E2E}"/>
               </a:ext>
             </a:extLst>
           </p:cNvPr>
@@ -7667,7 +7672,7 @@
     </p:spTree>
     <p:extLst>
       <p:ext uri="{BB962C8B-B14F-4D97-AF65-F5344CB8AC3E}">
-        <p14:creationId xmlns:p14="http://schemas.microsoft.com/office/powerpoint/2010/main" val="1801380449"/>
+        <p14:creationId xmlns:p14="http://schemas.microsoft.com/office/powerpoint/2010/main" val="636360127"/>
       </p:ext>
     </p:extLst>
   </p:cSld>
@@ -7698,7 +7703,7 @@
           <p:cNvPr id="28" name="">
             <a:extLst xmlns:a="http://schemas.openxmlformats.org/drawingml/2006/main">
               <a:ext uri="{FF2B5EF4-FFF2-40B4-BE49-F238E27FC236}">
-                <a16:creationId xmlns:a16="http://schemas.microsoft.com/office/drawing/2014/main" id="{D8C5AD34-6E37-4391-8A3D-30E425726762}"/>
+                <a16:creationId xmlns:a16="http://schemas.microsoft.com/office/drawing/2014/main" id="{3013F58B-00DC-458C-9DFA-699A12F9B779}"/>
               </a:ext>
             </a:extLst>
           </p:cNvPr>
@@ -7748,7 +7753,7 @@
           <p:cNvPr id="2" name="">
             <a:extLst xmlns:a="http://schemas.openxmlformats.org/drawingml/2006/main">
               <a:ext uri="{FF2B5EF4-FFF2-40B4-BE49-F238E27FC236}">
-                <a16:creationId xmlns:a16="http://schemas.microsoft.com/office/drawing/2014/main" id="{FE69E222-F643-4306-B595-C50C37728236}"/>
+                <a16:creationId xmlns:a16="http://schemas.microsoft.com/office/drawing/2014/main" id="{059B1D55-0599-4660-8839-D4EDA9F6EAFD}"/>
               </a:ext>
             </a:extLst>
           </p:cNvPr>
@@ -7798,7 +7803,7 @@
           <p:cNvPr id="3" name="">
             <a:extLst xmlns:a="http://schemas.openxmlformats.org/drawingml/2006/main">
               <a:ext uri="{FF2B5EF4-FFF2-40B4-BE49-F238E27FC236}">
-                <a16:creationId xmlns:a16="http://schemas.microsoft.com/office/drawing/2014/main" id="{7E11FA06-6B5E-4CCD-929F-97170EDAF6C0}"/>
+                <a16:creationId xmlns:a16="http://schemas.microsoft.com/office/drawing/2014/main" id="{89397C4D-0EF7-4019-AE38-377E357E8F01}"/>
               </a:ext>
             </a:extLst>
           </p:cNvPr>
@@ -7829,7 +7834,7 @@
           <p:cNvPr id="4" name="">
             <a:extLst xmlns:a="http://schemas.openxmlformats.org/drawingml/2006/main">
               <a:ext uri="{FF2B5EF4-FFF2-40B4-BE49-F238E27FC236}">
-                <a16:creationId xmlns:a16="http://schemas.microsoft.com/office/drawing/2014/main" id="{08DB647B-BDA1-42D3-9768-3160D9B9AAED}"/>
+                <a16:creationId xmlns:a16="http://schemas.microsoft.com/office/drawing/2014/main" id="{87CFF3C5-2E94-4EFC-987C-61ED26A1808B}"/>
               </a:ext>
             </a:extLst>
           </p:cNvPr>
@@ -7879,7 +7884,7 @@
           <p:cNvPr id="5" name="">
             <a:extLst xmlns:a="http://schemas.openxmlformats.org/drawingml/2006/main">
               <a:ext uri="{FF2B5EF4-FFF2-40B4-BE49-F238E27FC236}">
-                <a16:creationId xmlns:a16="http://schemas.microsoft.com/office/drawing/2014/main" id="{4CA4F781-7B33-4149-B2FF-27F6F919120E}"/>
+                <a16:creationId xmlns:a16="http://schemas.microsoft.com/office/drawing/2014/main" id="{C8DE400E-4C09-4F7F-81DD-99B325536E00}"/>
               </a:ext>
             </a:extLst>
           </p:cNvPr>
@@ -7929,7 +7934,7 @@
           <p:cNvPr id="6" name="">
             <a:extLst xmlns:a="http://schemas.openxmlformats.org/drawingml/2006/main">
               <a:ext uri="{FF2B5EF4-FFF2-40B4-BE49-F238E27FC236}">
-                <a16:creationId xmlns:a16="http://schemas.microsoft.com/office/drawing/2014/main" id="{5AFC4BB3-B1FC-4CEC-880B-DD626C257DCC}"/>
+                <a16:creationId xmlns:a16="http://schemas.microsoft.com/office/drawing/2014/main" id="{047FD840-ED6F-4F6B-ADC5-426A045A727C}"/>
               </a:ext>
             </a:extLst>
           </p:cNvPr>
@@ -7960,7 +7965,7 @@
           <p:cNvPr id="7" name="">
             <a:extLst xmlns:a="http://schemas.openxmlformats.org/drawingml/2006/main">
               <a:ext uri="{FF2B5EF4-FFF2-40B4-BE49-F238E27FC236}">
-                <a16:creationId xmlns:a16="http://schemas.microsoft.com/office/drawing/2014/main" id="{7D357856-738E-458B-8DA4-ADB42AF608C2}"/>
+                <a16:creationId xmlns:a16="http://schemas.microsoft.com/office/drawing/2014/main" id="{66B40ABC-8733-4B1E-9DB9-27ED03CDF464}"/>
               </a:ext>
             </a:extLst>
           </p:cNvPr>
@@ -8010,7 +8015,7 @@
           <p:cNvPr id="8" name="">
             <a:extLst xmlns:a="http://schemas.openxmlformats.org/drawingml/2006/main">
               <a:ext uri="{FF2B5EF4-FFF2-40B4-BE49-F238E27FC236}">
-                <a16:creationId xmlns:a16="http://schemas.microsoft.com/office/drawing/2014/main" id="{02892676-3007-45CE-A487-123CE713266F}"/>
+                <a16:creationId xmlns:a16="http://schemas.microsoft.com/office/drawing/2014/main" id="{C10F061A-96C1-416B-BB66-E17401C3C5E2}"/>
               </a:ext>
             </a:extLst>
           </p:cNvPr>
@@ -8060,7 +8065,7 @@
           <p:cNvPr id="9" name="">
             <a:extLst xmlns:a="http://schemas.openxmlformats.org/drawingml/2006/main">
               <a:ext uri="{FF2B5EF4-FFF2-40B4-BE49-F238E27FC236}">
-                <a16:creationId xmlns:a16="http://schemas.microsoft.com/office/drawing/2014/main" id="{0F737756-2395-481A-9808-B2D30C78AC28}"/>
+                <a16:creationId xmlns:a16="http://schemas.microsoft.com/office/drawing/2014/main" id="{FCA5C5DA-8801-4243-9716-20323D00B3F6}"/>
               </a:ext>
             </a:extLst>
           </p:cNvPr>
@@ -8091,7 +8096,7 @@
           <p:cNvPr id="10" name="">
             <a:extLst xmlns:a="http://schemas.openxmlformats.org/drawingml/2006/main">
               <a:ext uri="{FF2B5EF4-FFF2-40B4-BE49-F238E27FC236}">
-                <a16:creationId xmlns:a16="http://schemas.microsoft.com/office/drawing/2014/main" id="{EF2DB74B-103D-4B07-9F03-E83A05EDE50B}"/>
+                <a16:creationId xmlns:a16="http://schemas.microsoft.com/office/drawing/2014/main" id="{1298712E-3CD6-496D-A174-8332AFDBBB3E}"/>
               </a:ext>
             </a:extLst>
           </p:cNvPr>
@@ -8141,7 +8146,7 @@
           <p:cNvPr id="11" name="">
             <a:extLst xmlns:a="http://schemas.openxmlformats.org/drawingml/2006/main">
               <a:ext uri="{FF2B5EF4-FFF2-40B4-BE49-F238E27FC236}">
-                <a16:creationId xmlns:a16="http://schemas.microsoft.com/office/drawing/2014/main" id="{0DA09B5E-EA4C-4DB2-B12A-281A9C5F2C11}"/>
+                <a16:creationId xmlns:a16="http://schemas.microsoft.com/office/drawing/2014/main" id="{5FC680D8-450A-4992-902E-EE035765B3C5}"/>
               </a:ext>
             </a:extLst>
           </p:cNvPr>
@@ -8191,7 +8196,7 @@
           <p:cNvPr id="12" name="">
             <a:extLst xmlns:a="http://schemas.openxmlformats.org/drawingml/2006/main">
               <a:ext uri="{FF2B5EF4-FFF2-40B4-BE49-F238E27FC236}">
-                <a16:creationId xmlns:a16="http://schemas.microsoft.com/office/drawing/2014/main" id="{1F4B6003-6BF0-4737-BFCC-C19A385686D3}"/>
+                <a16:creationId xmlns:a16="http://schemas.microsoft.com/office/drawing/2014/main" id="{60D3CD70-BF25-4964-9A0E-841500EE0183}"/>
               </a:ext>
             </a:extLst>
           </p:cNvPr>
@@ -8222,7 +8227,7 @@
           <p:cNvPr id="13" name="">
             <a:extLst xmlns:a="http://schemas.openxmlformats.org/drawingml/2006/main">
               <a:ext uri="{FF2B5EF4-FFF2-40B4-BE49-F238E27FC236}">
-                <a16:creationId xmlns:a16="http://schemas.microsoft.com/office/drawing/2014/main" id="{2D81D38C-B1E3-4B80-8D2C-81556D7925E0}"/>
+                <a16:creationId xmlns:a16="http://schemas.microsoft.com/office/drawing/2014/main" id="{6D0BE47C-2AF3-4AFA-8F35-9E0F18483D99}"/>
               </a:ext>
             </a:extLst>
           </p:cNvPr>
@@ -8272,7 +8277,7 @@
           <p:cNvPr id="14" name="">
             <a:extLst xmlns:a="http://schemas.openxmlformats.org/drawingml/2006/main">
               <a:ext uri="{FF2B5EF4-FFF2-40B4-BE49-F238E27FC236}">
-                <a16:creationId xmlns:a16="http://schemas.microsoft.com/office/drawing/2014/main" id="{F8F752D8-F0BD-4CA6-AF34-A3D3EF9B245E}"/>
+                <a16:creationId xmlns:a16="http://schemas.microsoft.com/office/drawing/2014/main" id="{EA60CA00-AD0E-41B5-808E-3902C872189D}"/>
               </a:ext>
             </a:extLst>
           </p:cNvPr>
@@ -8322,7 +8327,7 @@
           <p:cNvPr id="15" name="">
             <a:extLst xmlns:a="http://schemas.openxmlformats.org/drawingml/2006/main">
               <a:ext uri="{FF2B5EF4-FFF2-40B4-BE49-F238E27FC236}">
-                <a16:creationId xmlns:a16="http://schemas.microsoft.com/office/drawing/2014/main" id="{94F0ECF7-C895-48B6-BB24-5E94BE616300}"/>
+                <a16:creationId xmlns:a16="http://schemas.microsoft.com/office/drawing/2014/main" id="{8971EBE9-E3D1-4957-8FAF-89470AA1CF36}"/>
               </a:ext>
             </a:extLst>
           </p:cNvPr>
@@ -8372,7 +8377,7 @@
           <p:cNvPr id="16" name="">
             <a:extLst xmlns:a="http://schemas.openxmlformats.org/drawingml/2006/main">
               <a:ext uri="{FF2B5EF4-FFF2-40B4-BE49-F238E27FC236}">
-                <a16:creationId xmlns:a16="http://schemas.microsoft.com/office/drawing/2014/main" id="{F8934BF4-325B-41B7-B148-58EFC3C501F7}"/>
+                <a16:creationId xmlns:a16="http://schemas.microsoft.com/office/drawing/2014/main" id="{DF06A10E-4AE7-462E-8C6B-7157746BD438}"/>
               </a:ext>
             </a:extLst>
           </p:cNvPr>
@@ -8403,7 +8408,7 @@
           <p:cNvPr id="17" name="">
             <a:extLst xmlns:a="http://schemas.openxmlformats.org/drawingml/2006/main">
               <a:ext uri="{FF2B5EF4-FFF2-40B4-BE49-F238E27FC236}">
-                <a16:creationId xmlns:a16="http://schemas.microsoft.com/office/drawing/2014/main" id="{F3933AB9-B76E-42AD-8419-E3E1299C6960}"/>
+                <a16:creationId xmlns:a16="http://schemas.microsoft.com/office/drawing/2014/main" id="{207F44AF-D0A2-4F01-A2D9-E7288B278D27}"/>
               </a:ext>
             </a:extLst>
           </p:cNvPr>
@@ -8453,7 +8458,7 @@
           <p:cNvPr id="18" name="">
             <a:extLst xmlns:a="http://schemas.openxmlformats.org/drawingml/2006/main">
               <a:ext uri="{FF2B5EF4-FFF2-40B4-BE49-F238E27FC236}">
-                <a16:creationId xmlns:a16="http://schemas.microsoft.com/office/drawing/2014/main" id="{AE445D82-BEFE-429B-929A-B56EE79256D7}"/>
+                <a16:creationId xmlns:a16="http://schemas.microsoft.com/office/drawing/2014/main" id="{68D279A2-7156-473C-8FED-97CF5769C00D}"/>
               </a:ext>
             </a:extLst>
           </p:cNvPr>
@@ -8503,7 +8508,7 @@
           <p:cNvPr id="19" name="">
             <a:extLst xmlns:a="http://schemas.openxmlformats.org/drawingml/2006/main">
               <a:ext uri="{FF2B5EF4-FFF2-40B4-BE49-F238E27FC236}">
-                <a16:creationId xmlns:a16="http://schemas.microsoft.com/office/drawing/2014/main" id="{C7BEF9A6-8BFF-4AFF-8CB0-30A9988A3086}"/>
+                <a16:creationId xmlns:a16="http://schemas.microsoft.com/office/drawing/2014/main" id="{24515D83-9FFC-4822-946A-A1614F434114}"/>
               </a:ext>
             </a:extLst>
           </p:cNvPr>
@@ -8534,7 +8539,7 @@
           <p:cNvPr id="20" name="">
             <a:extLst xmlns:a="http://schemas.openxmlformats.org/drawingml/2006/main">
               <a:ext uri="{FF2B5EF4-FFF2-40B4-BE49-F238E27FC236}">
-                <a16:creationId xmlns:a16="http://schemas.microsoft.com/office/drawing/2014/main" id="{09122741-70C1-4812-8829-93D73BBA0781}"/>
+                <a16:creationId xmlns:a16="http://schemas.microsoft.com/office/drawing/2014/main" id="{36CADB35-2EBB-42D6-B248-AC7819DB837F}"/>
               </a:ext>
             </a:extLst>
           </p:cNvPr>
@@ -8584,7 +8589,7 @@
           <p:cNvPr id="21" name="">
             <a:extLst xmlns:a="http://schemas.openxmlformats.org/drawingml/2006/main">
               <a:ext uri="{FF2B5EF4-FFF2-40B4-BE49-F238E27FC236}">
-                <a16:creationId xmlns:a16="http://schemas.microsoft.com/office/drawing/2014/main" id="{E729DCB5-A69E-4710-A316-7425EB3DAEAA}"/>
+                <a16:creationId xmlns:a16="http://schemas.microsoft.com/office/drawing/2014/main" id="{BE68C520-19D7-4262-B4B0-64ABE690DAFD}"/>
               </a:ext>
             </a:extLst>
           </p:cNvPr>
@@ -8634,7 +8639,7 @@
           <p:cNvPr id="22" name="">
             <a:extLst xmlns:a="http://schemas.openxmlformats.org/drawingml/2006/main">
               <a:ext uri="{FF2B5EF4-FFF2-40B4-BE49-F238E27FC236}">
-                <a16:creationId xmlns:a16="http://schemas.microsoft.com/office/drawing/2014/main" id="{A7A73104-1609-42E6-8301-666A97F67A53}"/>
+                <a16:creationId xmlns:a16="http://schemas.microsoft.com/office/drawing/2014/main" id="{44B1E047-915B-4A55-B3C2-681CB68A4CF0}"/>
               </a:ext>
             </a:extLst>
           </p:cNvPr>
@@ -8665,7 +8670,7 @@
           <p:cNvPr id="23" name="">
             <a:extLst xmlns:a="http://schemas.openxmlformats.org/drawingml/2006/main">
               <a:ext uri="{FF2B5EF4-FFF2-40B4-BE49-F238E27FC236}">
-                <a16:creationId xmlns:a16="http://schemas.microsoft.com/office/drawing/2014/main" id="{A32A75AC-F3C5-4CBC-AFFB-2567C8EEAF03}"/>
+                <a16:creationId xmlns:a16="http://schemas.microsoft.com/office/drawing/2014/main" id="{D412BBB3-C96C-4B71-A445-C6E6B73F6623}"/>
               </a:ext>
             </a:extLst>
           </p:cNvPr>
@@ -8715,7 +8720,7 @@
           <p:cNvPr id="24" name="">
             <a:extLst xmlns:a="http://schemas.openxmlformats.org/drawingml/2006/main">
               <a:ext uri="{FF2B5EF4-FFF2-40B4-BE49-F238E27FC236}">
-                <a16:creationId xmlns:a16="http://schemas.microsoft.com/office/drawing/2014/main" id="{E2198AE1-9452-4BC1-8558-AFFEFB088DC1}"/>
+                <a16:creationId xmlns:a16="http://schemas.microsoft.com/office/drawing/2014/main" id="{425574CE-5311-446F-8D5A-0CAC8452046F}"/>
               </a:ext>
             </a:extLst>
           </p:cNvPr>
@@ -8765,7 +8770,7 @@
           <p:cNvPr id="25" name="">
             <a:extLst xmlns:a="http://schemas.openxmlformats.org/drawingml/2006/main">
               <a:ext uri="{FF2B5EF4-FFF2-40B4-BE49-F238E27FC236}">
-                <a16:creationId xmlns:a16="http://schemas.microsoft.com/office/drawing/2014/main" id="{AC584321-D060-451C-8568-FAC781C6DBCB}"/>
+                <a16:creationId xmlns:a16="http://schemas.microsoft.com/office/drawing/2014/main" id="{82E4F63D-2715-43DB-A15F-4DFF9EA8CCD8}"/>
               </a:ext>
             </a:extLst>
           </p:cNvPr>
@@ -8796,7 +8801,7 @@
           <p:cNvPr id="26" name="">
             <a:extLst xmlns:a="http://schemas.openxmlformats.org/drawingml/2006/main">
               <a:ext uri="{FF2B5EF4-FFF2-40B4-BE49-F238E27FC236}">
-                <a16:creationId xmlns:a16="http://schemas.microsoft.com/office/drawing/2014/main" id="{C8783555-3333-4E40-939B-36A4FC4A8531}"/>
+                <a16:creationId xmlns:a16="http://schemas.microsoft.com/office/drawing/2014/main" id="{41C52CEB-66AD-4C91-96C9-0EA30A2D92FC}"/>
               </a:ext>
             </a:extLst>
           </p:cNvPr>
@@ -8846,7 +8851,7 @@
           <p:cNvPr id="27" name="">
             <a:extLst xmlns:a="http://schemas.openxmlformats.org/drawingml/2006/main">
               <a:ext uri="{FF2B5EF4-FFF2-40B4-BE49-F238E27FC236}">
-                <a16:creationId xmlns:a16="http://schemas.microsoft.com/office/drawing/2014/main" id="{A0A025EB-ECE5-4F3A-9517-A6A9DF35837D}"/>
+                <a16:creationId xmlns:a16="http://schemas.microsoft.com/office/drawing/2014/main" id="{B4AD75B1-1D92-4201-B734-9075075971D7}"/>
               </a:ext>
             </a:extLst>
           </p:cNvPr>
@@ -8894,7 +8899,7 @@
     </p:spTree>
     <p:extLst>
       <p:ext uri="{BB962C8B-B14F-4D97-AF65-F5344CB8AC3E}">
-        <p14:creationId xmlns:p14="http://schemas.microsoft.com/office/powerpoint/2010/main" val="1580027388"/>
+        <p14:creationId xmlns:p14="http://schemas.microsoft.com/office/powerpoint/2010/main" val="546214459"/>
       </p:ext>
     </p:extLst>
   </p:cSld>
@@ -8925,7 +8930,7 @@
           <p:cNvPr id="8" name="">
             <a:extLst xmlns:a="http://schemas.openxmlformats.org/drawingml/2006/main">
               <a:ext uri="{FF2B5EF4-FFF2-40B4-BE49-F238E27FC236}">
-                <a16:creationId xmlns:a16="http://schemas.microsoft.com/office/drawing/2014/main" id="{BFCB1F99-7CA9-424C-B6DA-5E13BCCF1234}"/>
+                <a16:creationId xmlns:a16="http://schemas.microsoft.com/office/drawing/2014/main" id="{F2528ADC-A380-4EB8-BE63-C4F95A56B953}"/>
               </a:ext>
             </a:extLst>
           </p:cNvPr>
@@ -8975,7 +8980,7 @@
           <p:cNvPr id="2" name="">
             <a:extLst xmlns:a="http://schemas.openxmlformats.org/drawingml/2006/main">
               <a:ext uri="{FF2B5EF4-FFF2-40B4-BE49-F238E27FC236}">
-                <a16:creationId xmlns:a16="http://schemas.microsoft.com/office/drawing/2014/main" id="{8B19E2EA-D5A8-49B5-AD0E-3927BD6E7D7E}"/>
+                <a16:creationId xmlns:a16="http://schemas.microsoft.com/office/drawing/2014/main" id="{3CED6E26-CCCE-4CEE-9E14-50C774B1EE5C}"/>
               </a:ext>
             </a:extLst>
           </p:cNvPr>
@@ -9025,7 +9030,7 @@
           <p:cNvPr id="3" name="">
             <a:extLst xmlns:a="http://schemas.openxmlformats.org/drawingml/2006/main">
               <a:ext uri="{FF2B5EF4-FFF2-40B4-BE49-F238E27FC236}">
-                <a16:creationId xmlns:a16="http://schemas.microsoft.com/office/drawing/2014/main" id="{E1CE25B5-DD7C-4C10-A43D-A98A82CA8C4D}"/>
+                <a16:creationId xmlns:a16="http://schemas.microsoft.com/office/drawing/2014/main" id="{F70B9A3F-16FB-47ED-87FA-3809CE417B64}"/>
               </a:ext>
             </a:extLst>
           </p:cNvPr>
@@ -9060,7 +9065,7 @@
           <p:nvPr/>
         </p:nvPicPr>
         <p:blipFill>
-          <a:blip xmlns:r="http://schemas.openxmlformats.org/officeDocument/2006/relationships" xmlns:a="http://schemas.openxmlformats.org/drawingml/2006/main" r:embed="Rd6401b68a6e94773"/>
+          <a:blip xmlns:r="http://schemas.openxmlformats.org/officeDocument/2006/relationships" xmlns:a="http://schemas.openxmlformats.org/drawingml/2006/main" r:embed="R1c02d6f2b4314b3f"/>
           <a:stretch xmlns:a="http://schemas.openxmlformats.org/drawingml/2006/main"/>
         </p:blipFill>
         <p:spPr>
@@ -9082,7 +9087,7 @@
           <p:nvPr/>
         </p:nvPicPr>
         <p:blipFill>
-          <a:blip xmlns:r="http://schemas.openxmlformats.org/officeDocument/2006/relationships" xmlns:a="http://schemas.openxmlformats.org/drawingml/2006/main" r:embed="R25de5b33d2a949fb"/>
+          <a:blip xmlns:r="http://schemas.openxmlformats.org/officeDocument/2006/relationships" xmlns:a="http://schemas.openxmlformats.org/drawingml/2006/main" r:embed="R8bb9fff49c224d42"/>
           <a:stretch xmlns:a="http://schemas.openxmlformats.org/drawingml/2006/main"/>
         </p:blipFill>
         <p:spPr>
@@ -9100,7 +9105,7 @@
           <p:cNvPr id="6" name="">
             <a:extLst xmlns:a="http://schemas.openxmlformats.org/drawingml/2006/main">
               <a:ext uri="{FF2B5EF4-FFF2-40B4-BE49-F238E27FC236}">
-                <a16:creationId xmlns:a16="http://schemas.microsoft.com/office/drawing/2014/main" id="{CA9854BF-92C8-42FE-A9FC-1BFA60B1E9B0}"/>
+                <a16:creationId xmlns:a16="http://schemas.microsoft.com/office/drawing/2014/main" id="{1B3CEEAB-3E46-47C9-B1F5-350BBC008299}"/>
               </a:ext>
             </a:extLst>
           </p:cNvPr>
@@ -9150,7 +9155,7 @@
           <p:cNvPr id="7" name="">
             <a:extLst xmlns:a="http://schemas.openxmlformats.org/drawingml/2006/main">
               <a:ext uri="{FF2B5EF4-FFF2-40B4-BE49-F238E27FC236}">
-                <a16:creationId xmlns:a16="http://schemas.microsoft.com/office/drawing/2014/main" id="{62319E1C-58ED-44B6-928A-51C62DF866BA}"/>
+                <a16:creationId xmlns:a16="http://schemas.microsoft.com/office/drawing/2014/main" id="{DB84596E-68BA-429E-B282-88D0BDB3BAEC}"/>
               </a:ext>
             </a:extLst>
           </p:cNvPr>
@@ -9198,7 +9203,7 @@
     </p:spTree>
     <p:extLst>
       <p:ext uri="{BB962C8B-B14F-4D97-AF65-F5344CB8AC3E}">
-        <p14:creationId xmlns:p14="http://schemas.microsoft.com/office/powerpoint/2010/main" val="869364236"/>
+        <p14:creationId xmlns:p14="http://schemas.microsoft.com/office/powerpoint/2010/main" val="1717432517"/>
       </p:ext>
     </p:extLst>
   </p:cSld>
@@ -9229,7 +9234,7 @@
           <p:cNvPr id="18" name="">
             <a:extLst xmlns:a="http://schemas.openxmlformats.org/drawingml/2006/main">
               <a:ext uri="{FF2B5EF4-FFF2-40B4-BE49-F238E27FC236}">
-                <a16:creationId xmlns:a16="http://schemas.microsoft.com/office/drawing/2014/main" id="{C4F804A7-C782-4F92-A720-CC97C0CDC7E7}"/>
+                <a16:creationId xmlns:a16="http://schemas.microsoft.com/office/drawing/2014/main" id="{1EB79FC8-EC22-44EF-ADC0-C83027D1E953}"/>
               </a:ext>
             </a:extLst>
           </p:cNvPr>
@@ -9279,7 +9284,7 @@
           <p:cNvPr id="2" name="">
             <a:extLst xmlns:a="http://schemas.openxmlformats.org/drawingml/2006/main">
               <a:ext uri="{FF2B5EF4-FFF2-40B4-BE49-F238E27FC236}">
-                <a16:creationId xmlns:a16="http://schemas.microsoft.com/office/drawing/2014/main" id="{58AA71FD-AF26-43E8-9B75-AD198A259A97}"/>
+                <a16:creationId xmlns:a16="http://schemas.microsoft.com/office/drawing/2014/main" id="{20C0B570-5149-4401-93B8-2DAD9C86E416}"/>
               </a:ext>
             </a:extLst>
           </p:cNvPr>
@@ -9329,7 +9334,7 @@
           <p:cNvPr id="3" name="">
             <a:extLst xmlns:a="http://schemas.openxmlformats.org/drawingml/2006/main">
               <a:ext uri="{FF2B5EF4-FFF2-40B4-BE49-F238E27FC236}">
-                <a16:creationId xmlns:a16="http://schemas.microsoft.com/office/drawing/2014/main" id="{AC530B5C-CEBB-42DD-97EB-E67DB71B880F}"/>
+                <a16:creationId xmlns:a16="http://schemas.microsoft.com/office/drawing/2014/main" id="{C4EBE61D-DFC0-4B05-BC76-5F9F954FEEAC}"/>
               </a:ext>
             </a:extLst>
           </p:cNvPr>
@@ -9360,7 +9365,7 @@
           <p:cNvPr id="4" name="">
             <a:extLst xmlns:a="http://schemas.openxmlformats.org/drawingml/2006/main">
               <a:ext uri="{FF2B5EF4-FFF2-40B4-BE49-F238E27FC236}">
-                <a16:creationId xmlns:a16="http://schemas.microsoft.com/office/drawing/2014/main" id="{F1CEE5E8-990F-4E62-9E84-790C5F556DDD}"/>
+                <a16:creationId xmlns:a16="http://schemas.microsoft.com/office/drawing/2014/main" id="{6740E48D-4440-468A-A4A2-B565E2C4C148}"/>
               </a:ext>
             </a:extLst>
           </p:cNvPr>
@@ -9391,7 +9396,7 @@
           <p:cNvPr id="5" name="">
             <a:extLst xmlns:a="http://schemas.openxmlformats.org/drawingml/2006/main">
               <a:ext uri="{FF2B5EF4-FFF2-40B4-BE49-F238E27FC236}">
-                <a16:creationId xmlns:a16="http://schemas.microsoft.com/office/drawing/2014/main" id="{B09AAD2D-641A-4060-8B8D-AAB696D361F3}"/>
+                <a16:creationId xmlns:a16="http://schemas.microsoft.com/office/drawing/2014/main" id="{3FFCE939-1CE5-4A41-AF1C-F7BA268556FB}"/>
               </a:ext>
             </a:extLst>
           </p:cNvPr>
@@ -9441,7 +9446,7 @@
           <p:cNvPr id="6" name="">
             <a:extLst xmlns:a="http://schemas.openxmlformats.org/drawingml/2006/main">
               <a:ext uri="{FF2B5EF4-FFF2-40B4-BE49-F238E27FC236}">
-                <a16:creationId xmlns:a16="http://schemas.microsoft.com/office/drawing/2014/main" id="{B9A176ED-E9DE-4B3B-B373-99A1CBB2BA79}"/>
+                <a16:creationId xmlns:a16="http://schemas.microsoft.com/office/drawing/2014/main" id="{198FDA64-955E-42F7-9BEF-8196F628E9A8}"/>
               </a:ext>
             </a:extLst>
           </p:cNvPr>
@@ -9491,7 +9496,7 @@
           <p:cNvPr id="7" name="">
             <a:extLst xmlns:a="http://schemas.openxmlformats.org/drawingml/2006/main">
               <a:ext uri="{FF2B5EF4-FFF2-40B4-BE49-F238E27FC236}">
-                <a16:creationId xmlns:a16="http://schemas.microsoft.com/office/drawing/2014/main" id="{F9301097-5C7C-4DE2-B54E-61813A623466}"/>
+                <a16:creationId xmlns:a16="http://schemas.microsoft.com/office/drawing/2014/main" id="{D6A59A4F-6859-4DE7-8C6E-A291D51477F0}"/>
               </a:ext>
             </a:extLst>
           </p:cNvPr>
@@ -9541,7 +9546,7 @@
           <p:cNvPr id="8" name="">
             <a:extLst xmlns:a="http://schemas.openxmlformats.org/drawingml/2006/main">
               <a:ext uri="{FF2B5EF4-FFF2-40B4-BE49-F238E27FC236}">
-                <a16:creationId xmlns:a16="http://schemas.microsoft.com/office/drawing/2014/main" id="{886D2669-0A4B-474D-B2D6-B9C6DF85E424}"/>
+                <a16:creationId xmlns:a16="http://schemas.microsoft.com/office/drawing/2014/main" id="{D8901063-4CA3-456B-AD52-2D4BC6F6DB9B}"/>
               </a:ext>
             </a:extLst>
           </p:cNvPr>
@@ -9591,7 +9596,7 @@
           <p:cNvPr id="9" name="">
             <a:extLst xmlns:a="http://schemas.openxmlformats.org/drawingml/2006/main">
               <a:ext uri="{FF2B5EF4-FFF2-40B4-BE49-F238E27FC236}">
-                <a16:creationId xmlns:a16="http://schemas.microsoft.com/office/drawing/2014/main" id="{2AA69714-8ADD-4F13-B9AB-DB63AFCBD4F4}"/>
+                <a16:creationId xmlns:a16="http://schemas.microsoft.com/office/drawing/2014/main" id="{57A57E18-34D2-423F-877E-FC38EA13357F}"/>
               </a:ext>
             </a:extLst>
           </p:cNvPr>
@@ -9622,7 +9627,7 @@
           <p:cNvPr id="10" name="">
             <a:extLst xmlns:a="http://schemas.openxmlformats.org/drawingml/2006/main">
               <a:ext uri="{FF2B5EF4-FFF2-40B4-BE49-F238E27FC236}">
-                <a16:creationId xmlns:a16="http://schemas.microsoft.com/office/drawing/2014/main" id="{4F8F0309-BFA5-4A54-927A-E8D59F4C6A5F}"/>
+                <a16:creationId xmlns:a16="http://schemas.microsoft.com/office/drawing/2014/main" id="{4DA84297-90C8-4AF7-886A-742EA56779CA}"/>
               </a:ext>
             </a:extLst>
           </p:cNvPr>
@@ -9672,7 +9677,7 @@
           <p:cNvPr id="11" name="">
             <a:extLst xmlns:a="http://schemas.openxmlformats.org/drawingml/2006/main">
               <a:ext uri="{FF2B5EF4-FFF2-40B4-BE49-F238E27FC236}">
-                <a16:creationId xmlns:a16="http://schemas.microsoft.com/office/drawing/2014/main" id="{99A638C1-FEC0-42F1-BBF1-0AA51B7F95A3}"/>
+                <a16:creationId xmlns:a16="http://schemas.microsoft.com/office/drawing/2014/main" id="{BCBF7604-FA85-4C48-9052-DB9FF948C454}"/>
               </a:ext>
             </a:extLst>
           </p:cNvPr>
@@ -9722,7 +9727,7 @@
           <p:cNvPr id="12" name="">
             <a:extLst xmlns:a="http://schemas.openxmlformats.org/drawingml/2006/main">
               <a:ext uri="{FF2B5EF4-FFF2-40B4-BE49-F238E27FC236}">
-                <a16:creationId xmlns:a16="http://schemas.microsoft.com/office/drawing/2014/main" id="{00F78CB5-4C5C-4EF5-BBFC-2E13B201B6E0}"/>
+                <a16:creationId xmlns:a16="http://schemas.microsoft.com/office/drawing/2014/main" id="{A0C90F6B-0653-4100-A88E-A9384231AE49}"/>
               </a:ext>
             </a:extLst>
           </p:cNvPr>
@@ -9772,7 +9777,7 @@
           <p:cNvPr id="13" name="">
             <a:extLst xmlns:a="http://schemas.openxmlformats.org/drawingml/2006/main">
               <a:ext uri="{FF2B5EF4-FFF2-40B4-BE49-F238E27FC236}">
-                <a16:creationId xmlns:a16="http://schemas.microsoft.com/office/drawing/2014/main" id="{0DB0DDE1-4F2D-4A14-BD4B-382716227C26}"/>
+                <a16:creationId xmlns:a16="http://schemas.microsoft.com/office/drawing/2014/main" id="{F9F072DC-5886-4746-AF36-E365445CB266}"/>
               </a:ext>
             </a:extLst>
           </p:cNvPr>
@@ -9822,7 +9827,7 @@
           <p:cNvPr id="14" name="">
             <a:extLst xmlns:a="http://schemas.openxmlformats.org/drawingml/2006/main">
               <a:ext uri="{FF2B5EF4-FFF2-40B4-BE49-F238E27FC236}">
-                <a16:creationId xmlns:a16="http://schemas.microsoft.com/office/drawing/2014/main" id="{197CEE0A-5C66-4B06-BFA5-98D57C75438E}"/>
+                <a16:creationId xmlns:a16="http://schemas.microsoft.com/office/drawing/2014/main" id="{FE8B788B-9CE1-41C9-A452-20F1D52B36AA}"/>
               </a:ext>
             </a:extLst>
           </p:cNvPr>
@@ -9853,7 +9858,7 @@
           <p:cNvPr id="15" name="">
             <a:extLst xmlns:a="http://schemas.openxmlformats.org/drawingml/2006/main">
               <a:ext uri="{FF2B5EF4-FFF2-40B4-BE49-F238E27FC236}">
-                <a16:creationId xmlns:a16="http://schemas.microsoft.com/office/drawing/2014/main" id="{D4F63BF6-6168-4CC0-A478-7528429FDAC9}"/>
+                <a16:creationId xmlns:a16="http://schemas.microsoft.com/office/drawing/2014/main" id="{C4C25EAC-D0D4-46BD-8C74-DE829E3D44AA}"/>
               </a:ext>
             </a:extLst>
           </p:cNvPr>
@@ -9903,7 +9908,7 @@
           <p:cNvPr id="16" name="">
             <a:extLst xmlns:a="http://schemas.openxmlformats.org/drawingml/2006/main">
               <a:ext uri="{FF2B5EF4-FFF2-40B4-BE49-F238E27FC236}">
-                <a16:creationId xmlns:a16="http://schemas.microsoft.com/office/drawing/2014/main" id="{9D9C1444-11A2-4D5D-827A-1B34FBF0F492}"/>
+                <a16:creationId xmlns:a16="http://schemas.microsoft.com/office/drawing/2014/main" id="{4E2758DC-8C1B-4E5F-B25B-D9FDC00FFE96}"/>
               </a:ext>
             </a:extLst>
           </p:cNvPr>
@@ -9953,7 +9958,7 @@
           <p:cNvPr id="17" name="">
             <a:extLst xmlns:a="http://schemas.openxmlformats.org/drawingml/2006/main">
               <a:ext uri="{FF2B5EF4-FFF2-40B4-BE49-F238E27FC236}">
-                <a16:creationId xmlns:a16="http://schemas.microsoft.com/office/drawing/2014/main" id="{640B003B-9EAF-40A9-A60A-4673E463302A}"/>
+                <a16:creationId xmlns:a16="http://schemas.microsoft.com/office/drawing/2014/main" id="{7EA6EE05-CFA7-4129-A106-E39F1509CF60}"/>
               </a:ext>
             </a:extLst>
           </p:cNvPr>
@@ -10001,7 +10006,7 @@
     </p:spTree>
     <p:extLst>
       <p:ext uri="{BB962C8B-B14F-4D97-AF65-F5344CB8AC3E}">
-        <p14:creationId xmlns:p14="http://schemas.microsoft.com/office/powerpoint/2010/main" val="1022479521"/>
+        <p14:creationId xmlns:p14="http://schemas.microsoft.com/office/powerpoint/2010/main" val="1352938796"/>
       </p:ext>
     </p:extLst>
   </p:cSld>
@@ -10032,7 +10037,7 @@
           <p:cNvPr id="7" name="">
             <a:extLst xmlns:a="http://schemas.openxmlformats.org/drawingml/2006/main">
               <a:ext uri="{FF2B5EF4-FFF2-40B4-BE49-F238E27FC236}">
-                <a16:creationId xmlns:a16="http://schemas.microsoft.com/office/drawing/2014/main" id="{B265319D-A366-4187-981C-7EAD6BDE156E}"/>
+                <a16:creationId xmlns:a16="http://schemas.microsoft.com/office/drawing/2014/main" id="{15E9DA7E-2BC1-4920-817A-B3037800C361}"/>
               </a:ext>
             </a:extLst>
           </p:cNvPr>
@@ -10082,7 +10087,7 @@
           <p:cNvPr id="2" name="">
             <a:extLst xmlns:a="http://schemas.openxmlformats.org/drawingml/2006/main">
               <a:ext uri="{FF2B5EF4-FFF2-40B4-BE49-F238E27FC236}">
-                <a16:creationId xmlns:a16="http://schemas.microsoft.com/office/drawing/2014/main" id="{A1CD3505-2B8B-4566-8BE4-7E5CF95F1414}"/>
+                <a16:creationId xmlns:a16="http://schemas.microsoft.com/office/drawing/2014/main" id="{BA3ED96A-F1E5-4E6F-9148-B2AF21E958DF}"/>
               </a:ext>
             </a:extLst>
           </p:cNvPr>
@@ -10132,7 +10137,7 @@
           <p:cNvPr id="3" name="">
             <a:extLst xmlns:a="http://schemas.openxmlformats.org/drawingml/2006/main">
               <a:ext uri="{FF2B5EF4-FFF2-40B4-BE49-F238E27FC236}">
-                <a16:creationId xmlns:a16="http://schemas.microsoft.com/office/drawing/2014/main" id="{566994CB-0E10-4A29-9526-025DDA5F74F5}"/>
+                <a16:creationId xmlns:a16="http://schemas.microsoft.com/office/drawing/2014/main" id="{96A4B228-0057-49FB-B748-957F03C110B8}"/>
               </a:ext>
             </a:extLst>
           </p:cNvPr>
@@ -10167,7 +10172,7 @@
           <p:nvPr/>
         </p:nvPicPr>
         <p:blipFill>
-          <a:blip xmlns:r="http://schemas.openxmlformats.org/officeDocument/2006/relationships" xmlns:a="http://schemas.openxmlformats.org/drawingml/2006/main" r:embed="Ra91bd0c00cec4c1f"/>
+          <a:blip xmlns:r="http://schemas.openxmlformats.org/officeDocument/2006/relationships" xmlns:a="http://schemas.openxmlformats.org/drawingml/2006/main" r:embed="Rc82b78dfdefa46a5"/>
           <a:srcRect xmlns:a="http://schemas.openxmlformats.org/drawingml/2006/main" l="0" t="877" r="0" b="877"/>
           <a:stretch xmlns:a="http://schemas.openxmlformats.org/drawingml/2006/main">
             <a:fillRect l="0" t="0" r="0" b="0"/>
@@ -10188,7 +10193,7 @@
           <p:cNvPr id="5" name="">
             <a:extLst xmlns:a="http://schemas.openxmlformats.org/drawingml/2006/main">
               <a:ext uri="{FF2B5EF4-FFF2-40B4-BE49-F238E27FC236}">
-                <a16:creationId xmlns:a16="http://schemas.microsoft.com/office/drawing/2014/main" id="{7514C37F-2023-4046-A419-8835B6FBF3B1}"/>
+                <a16:creationId xmlns:a16="http://schemas.microsoft.com/office/drawing/2014/main" id="{FC492FF5-A5F5-4204-A923-D263DF95D307}"/>
               </a:ext>
             </a:extLst>
           </p:cNvPr>
@@ -10238,7 +10243,7 @@
           <p:cNvPr id="6" name="">
             <a:extLst xmlns:a="http://schemas.openxmlformats.org/drawingml/2006/main">
               <a:ext uri="{FF2B5EF4-FFF2-40B4-BE49-F238E27FC236}">
-                <a16:creationId xmlns:a16="http://schemas.microsoft.com/office/drawing/2014/main" id="{36C9FDCC-CF25-4026-B36D-89C065074B9D}"/>
+                <a16:creationId xmlns:a16="http://schemas.microsoft.com/office/drawing/2014/main" id="{D4FFA984-3196-4AF3-8266-DB5B0F7428C8}"/>
               </a:ext>
             </a:extLst>
           </p:cNvPr>
@@ -10330,7 +10335,7 @@
     </p:spTree>
     <p:extLst>
       <p:ext uri="{BB962C8B-B14F-4D97-AF65-F5344CB8AC3E}">
-        <p14:creationId xmlns:p14="http://schemas.microsoft.com/office/powerpoint/2010/main" val="344378935"/>
+        <p14:creationId xmlns:p14="http://schemas.microsoft.com/office/powerpoint/2010/main" val="2098305430"/>
       </p:ext>
     </p:extLst>
   </p:cSld>
@@ -10361,7 +10366,7 @@
           <p:cNvPr id="8" name="">
             <a:extLst xmlns:a="http://schemas.openxmlformats.org/drawingml/2006/main">
               <a:ext uri="{FF2B5EF4-FFF2-40B4-BE49-F238E27FC236}">
-                <a16:creationId xmlns:a16="http://schemas.microsoft.com/office/drawing/2014/main" id="{84EDEF5C-9D5F-4CCE-87B6-5A114E4F18BF}"/>
+                <a16:creationId xmlns:a16="http://schemas.microsoft.com/office/drawing/2014/main" id="{52EBAA32-0A77-4B69-BA3F-DB3D30BEE945}"/>
               </a:ext>
             </a:extLst>
           </p:cNvPr>
@@ -10411,7 +10416,7 @@
           <p:cNvPr id="2" name="">
             <a:extLst xmlns:a="http://schemas.openxmlformats.org/drawingml/2006/main">
               <a:ext uri="{FF2B5EF4-FFF2-40B4-BE49-F238E27FC236}">
-                <a16:creationId xmlns:a16="http://schemas.microsoft.com/office/drawing/2014/main" id="{B542D2F2-33EB-4888-8677-E0FF1FAD2F4A}"/>
+                <a16:creationId xmlns:a16="http://schemas.microsoft.com/office/drawing/2014/main" id="{E4CD1CF2-76F4-44B9-BF71-8D42F1EA0DFB}"/>
               </a:ext>
             </a:extLst>
           </p:cNvPr>
@@ -10461,7 +10466,7 @@
           <p:cNvPr id="3" name="">
             <a:extLst xmlns:a="http://schemas.openxmlformats.org/drawingml/2006/main">
               <a:ext uri="{FF2B5EF4-FFF2-40B4-BE49-F238E27FC236}">
-                <a16:creationId xmlns:a16="http://schemas.microsoft.com/office/drawing/2014/main" id="{9BC7D96F-D1B1-40F2-802A-4BB4F9ACA262}"/>
+                <a16:creationId xmlns:a16="http://schemas.microsoft.com/office/drawing/2014/main" id="{86656AF5-5E3A-4980-BCCE-666B99480DFA}"/>
               </a:ext>
             </a:extLst>
           </p:cNvPr>
@@ -10496,7 +10501,7 @@
           <p:nvPr/>
         </p:nvPicPr>
         <p:blipFill>
-          <a:blip xmlns:r="http://schemas.openxmlformats.org/officeDocument/2006/relationships" xmlns:a="http://schemas.openxmlformats.org/drawingml/2006/main" r:embed="Rf433121f516340bc"/>
+          <a:blip xmlns:r="http://schemas.openxmlformats.org/officeDocument/2006/relationships" xmlns:a="http://schemas.openxmlformats.org/drawingml/2006/main" r:embed="R3a162c83700c4abc"/>
           <a:stretch xmlns:a="http://schemas.openxmlformats.org/drawingml/2006/main"/>
         </p:blipFill>
         <p:spPr>
@@ -10514,7 +10519,7 @@
           <p:cNvPr id="5" name="">
             <a:extLst xmlns:a="http://schemas.openxmlformats.org/drawingml/2006/main">
               <a:ext uri="{FF2B5EF4-FFF2-40B4-BE49-F238E27FC236}">
-                <a16:creationId xmlns:a16="http://schemas.microsoft.com/office/drawing/2014/main" id="{12D9F14A-840B-4F82-B60A-D6E971156DC1}"/>
+                <a16:creationId xmlns:a16="http://schemas.microsoft.com/office/drawing/2014/main" id="{BFE14917-DFE8-4805-B55C-9C0D2D68B322}"/>
               </a:ext>
             </a:extLst>
           </p:cNvPr>
@@ -10564,7 +10569,7 @@
           <p:cNvPr id="6" name="">
             <a:extLst xmlns:a="http://schemas.openxmlformats.org/drawingml/2006/main">
               <a:ext uri="{FF2B5EF4-FFF2-40B4-BE49-F238E27FC236}">
-                <a16:creationId xmlns:a16="http://schemas.microsoft.com/office/drawing/2014/main" id="{3417B018-725F-4D68-BBF9-E507FCF3B742}"/>
+                <a16:creationId xmlns:a16="http://schemas.microsoft.com/office/drawing/2014/main" id="{8EF11495-3BC7-4412-9916-C12DF13BE93E}"/>
               </a:ext>
             </a:extLst>
           </p:cNvPr>
@@ -10614,7 +10619,7 @@
           <p:cNvPr id="7" name="">
             <a:extLst xmlns:a="http://schemas.openxmlformats.org/drawingml/2006/main">
               <a:ext uri="{FF2B5EF4-FFF2-40B4-BE49-F238E27FC236}">
-                <a16:creationId xmlns:a16="http://schemas.microsoft.com/office/drawing/2014/main" id="{26B7E87E-F083-4153-BDB3-BB9CC93B9B21}"/>
+                <a16:creationId xmlns:a16="http://schemas.microsoft.com/office/drawing/2014/main" id="{E119BE68-3EFC-4FA3-988F-38F4808EEE79}"/>
               </a:ext>
             </a:extLst>
           </p:cNvPr>
@@ -10662,7 +10667,7 @@
     </p:spTree>
     <p:extLst>
       <p:ext uri="{BB962C8B-B14F-4D97-AF65-F5344CB8AC3E}">
-        <p14:creationId xmlns:p14="http://schemas.microsoft.com/office/powerpoint/2010/main" val="848828213"/>
+        <p14:creationId xmlns:p14="http://schemas.microsoft.com/office/powerpoint/2010/main" val="87885137"/>
       </p:ext>
     </p:extLst>
   </p:cSld>

</xml_diff>